<commit_message>
Feat(Issue315,316): PPTX 산출을 ppt-* SCAR 3종 경유로 전환 — 테마·팔레트 반영
- lib/pptx/build-pptx.sh 신설: theme-from-css → theme2reference → md2pptx --m2slide
- deck.py 미사용 (폴백 ①이 m2slide.sh 로 되위임 → 상호 재귀). md2pptx 직접 호출로 회피
- palette 미지정 덱의 warm 오탐을 --kn-accent 로 교정
- 구 pandoc 직접 경로 폴백 제거 (조용한 품질 회귀 차단)

실측(igTest): accent 17 hits vs 0 · Malgun 193 vs 0 · #layout-* 누출 0 vs 5
</commit_message>
<xml_diff>
--- a/Projects/m2Slide/slide/m2Slide.pptx
+++ b/Projects/m2Slide/slide/m2Slide.pptx
@@ -12,14 +12,8 @@
     <p:sldId id="260" r:id="rId6"/>
     <p:sldId id="261" r:id="rId7"/>
     <p:sldId id="262" r:id="rId8"/>
-    <p:sldId id="263" r:id="rId9"/>
-    <p:sldId id="264" r:id="rId10"/>
-    <p:sldId id="265" r:id="rId11"/>
-    <p:sldId id="266" r:id="rId12"/>
-    <p:sldId id="267" r:id="rId13"/>
-    <p:sldId id="268" r:id="rId14"/>
   </p:sldIdLst>
-  <p:sldSz cx="9144000" cy="5143500" type="screen16x9"/>
+  <p:sldSz cx="12192120" cy="6858000" type="screen4x3"/>
   <p:notesSz cx="6858000" cy="9144000"/>
   <p:defaultTextStyle>
     <a:defPPr>
@@ -116,22 +110,6 @@
       </a:defRPr>
     </a:lvl9pPr>
   </p:defaultTextStyle>
-  <p:extLst>
-    <p:ext uri="{EFAFB233-063F-42B5-8137-9DF3F51BA10A}">
-      <p15:sldGuideLst xmlns:p15="http://schemas.microsoft.com/office/powerpoint/2012/main">
-        <p15:guide id="1" orient="horz" pos="1620" userDrawn="1">
-          <p15:clr>
-            <a:srgbClr val="A4A3A4"/>
-          </p15:clr>
-        </p15:guide>
-        <p15:guide id="2" pos="2880" userDrawn="1">
-          <p15:clr>
-            <a:srgbClr val="A4A3A4"/>
-          </p15:clr>
-        </p15:guide>
-      </p15:sldGuideLst>
-    </p:ext>
-  </p:extLst>
 </p:presentation>
 </file>
 
@@ -164,18 +142,30 @@
         </p:nvSpPr>
         <p:spPr>
           <a:xfrm>
-            <a:off x="685800" y="1597819"/>
-            <a:ext cx="7772400" cy="1102519"/>
+            <a:off x="685800" y="2130425"/>
+            <a:ext cx="7772400" cy="1470025"/>
           </a:xfrm>
         </p:spPr>
         <p:txBody>
           <a:bodyPr/>
-          <a:lstStyle/>
-          <a:p>
-            <a:r>
-              <a:rPr lang="en-US"/>
+          <a:lstStyle>
+            <a:lvl1pPr>
+              <a:defRPr sz="2700" b="1">
+                <a:solidFill>
+                  <a:srgbClr val="977A0E"/>
+                </a:solidFill>
+                <a:latin typeface="Malgun Gothic"/>
+                <a:ea typeface="Malgun Gothic"/>
+                <a:cs typeface="Malgun Gothic"/>
+              </a:defRPr>
+            </a:lvl1pPr>
+          </a:lstStyle>
+          <a:p>
+            <a:r>
+              <a:rPr lang="en-US" smtClean="0"/>
               <a:t>Click to edit Master title style</a:t>
             </a:r>
+            <a:endParaRPr lang="en-US"/>
           </a:p>
         </p:txBody>
       </p:sp>
@@ -191,109 +181,30 @@
         </p:nvSpPr>
         <p:spPr>
           <a:xfrm>
-            <a:off x="1371600" y="2914650"/>
-            <a:ext cx="6400800" cy="1314450"/>
+            <a:off x="1371600" y="3886200"/>
+            <a:ext cx="6400800" cy="1752600"/>
           </a:xfrm>
         </p:spPr>
         <p:txBody>
           <a:bodyPr/>
           <a:lstStyle>
-            <a:lvl1pPr marL="0" indent="0" algn="ctr">
-              <a:buNone/>
-              <a:defRPr>
-                <a:solidFill>
-                  <a:schemeClr val="tx1">
-                    <a:tint val="75000"/>
-                  </a:schemeClr>
-                </a:solidFill>
-              </a:defRPr>
-            </a:lvl1pPr>
-            <a:lvl2pPr marL="342900" indent="0" algn="ctr">
-              <a:buNone/>
-              <a:defRPr>
-                <a:solidFill>
-                  <a:schemeClr val="tx1">
-                    <a:tint val="75000"/>
-                  </a:schemeClr>
-                </a:solidFill>
-              </a:defRPr>
-            </a:lvl2pPr>
-            <a:lvl3pPr marL="685800" indent="0" algn="ctr">
-              <a:buNone/>
-              <a:defRPr>
-                <a:solidFill>
-                  <a:schemeClr val="tx1">
-                    <a:tint val="75000"/>
-                  </a:schemeClr>
-                </a:solidFill>
-              </a:defRPr>
-            </a:lvl3pPr>
-            <a:lvl4pPr marL="1028700" indent="0" algn="ctr">
-              <a:buNone/>
-              <a:defRPr>
-                <a:solidFill>
-                  <a:schemeClr val="tx1">
-                    <a:tint val="75000"/>
-                  </a:schemeClr>
-                </a:solidFill>
-              </a:defRPr>
-            </a:lvl4pPr>
-            <a:lvl5pPr marL="1371600" indent="0" algn="ctr">
-              <a:buNone/>
-              <a:defRPr>
-                <a:solidFill>
-                  <a:schemeClr val="tx1">
-                    <a:tint val="75000"/>
-                  </a:schemeClr>
-                </a:solidFill>
-              </a:defRPr>
-            </a:lvl5pPr>
-            <a:lvl6pPr marL="1714500" indent="0" algn="ctr">
-              <a:buNone/>
-              <a:defRPr>
-                <a:solidFill>
-                  <a:schemeClr val="tx1">
-                    <a:tint val="75000"/>
-                  </a:schemeClr>
-                </a:solidFill>
-              </a:defRPr>
-            </a:lvl6pPr>
-            <a:lvl7pPr marL="2057400" indent="0" algn="ctr">
-              <a:buNone/>
-              <a:defRPr>
-                <a:solidFill>
-                  <a:schemeClr val="tx1">
-                    <a:tint val="75000"/>
-                  </a:schemeClr>
-                </a:solidFill>
-              </a:defRPr>
-            </a:lvl7pPr>
-            <a:lvl8pPr marL="2400300" indent="0" algn="ctr">
-              <a:buNone/>
-              <a:defRPr>
-                <a:solidFill>
-                  <a:schemeClr val="tx1">
-                    <a:tint val="75000"/>
-                  </a:schemeClr>
-                </a:solidFill>
-              </a:defRPr>
-            </a:lvl8pPr>
-            <a:lvl9pPr marL="2743200" indent="0" algn="ctr">
-              <a:buNone/>
-              <a:defRPr>
-                <a:solidFill>
-                  <a:schemeClr val="tx1">
-                    <a:tint val="75000"/>
-                  </a:schemeClr>
-                </a:solidFill>
-              </a:defRPr>
-            </a:lvl9pPr>
-          </a:lstStyle>
-          <a:p>
-            <a:r>
-              <a:rPr lang="en-US"/>
+            <a:lvl1pPr>
+              <a:defRPr sz="950">
+                <a:solidFill>
+                  <a:srgbClr val="1A1A1A"/>
+                </a:solidFill>
+                <a:latin typeface="Malgun Gothic"/>
+                <a:ea typeface="Malgun Gothic"/>
+                <a:cs typeface="Malgun Gothic"/>
+              </a:defRPr>
+            </a:lvl1pPr>
+          </a:lstStyle>
+          <a:p>
+            <a:r>
+              <a:rPr lang="en-US" smtClean="0"/>
               <a:t>Click to edit Master subtitle style</a:t>
             </a:r>
+            <a:endParaRPr lang="en-US"/>
           </a:p>
         </p:txBody>
       </p:sp>
@@ -310,11 +221,22 @@
         <p:spPr/>
         <p:txBody>
           <a:bodyPr/>
-          <a:lstStyle/>
-          <a:p>
-            <a:fld id="{241EB5C9-1307-BA42-ABA2-0BC069CD8E7F}" type="datetimeFigureOut">
-              <a:rPr lang="en-US" smtClean="0"/>
-              <a:t>1/2/22</a:t>
+          <a:lstStyle>
+            <a:lvl1pPr>
+              <a:defRPr sz="950">
+                <a:solidFill>
+                  <a:srgbClr val="1A1A1A"/>
+                </a:solidFill>
+                <a:latin typeface="Malgun Gothic"/>
+                <a:ea typeface="Malgun Gothic"/>
+                <a:cs typeface="Malgun Gothic"/>
+              </a:defRPr>
+            </a:lvl1pPr>
+          </a:lstStyle>
+          <a:p>
+            <a:fld id="{5BCAD085-E8A6-8845-BD4E-CB4CCA059FC4}" type="datetimeFigureOut">
+              <a:rPr lang="en-US" smtClean="0"/>
+              <a:t>1/27/13</a:t>
             </a:fld>
             <a:endParaRPr lang="en-US"/>
           </a:p>
@@ -333,7 +255,18 @@
         <p:spPr/>
         <p:txBody>
           <a:bodyPr/>
-          <a:lstStyle/>
+          <a:lstStyle>
+            <a:lvl1pPr>
+              <a:defRPr sz="950">
+                <a:solidFill>
+                  <a:srgbClr val="1A1A1A"/>
+                </a:solidFill>
+                <a:latin typeface="Malgun Gothic"/>
+                <a:ea typeface="Malgun Gothic"/>
+                <a:cs typeface="Malgun Gothic"/>
+              </a:defRPr>
+            </a:lvl1pPr>
+          </a:lstStyle>
           <a:p>
             <a:endParaRPr lang="en-US"/>
           </a:p>
@@ -352,9 +285,20 @@
         <p:spPr/>
         <p:txBody>
           <a:bodyPr/>
-          <a:lstStyle/>
-          <a:p>
-            <a:fld id="{C5EF2332-01BF-834F-8236-50238282D533}" type="slidenum">
+          <a:lstStyle>
+            <a:lvl1pPr>
+              <a:defRPr sz="950">
+                <a:solidFill>
+                  <a:srgbClr val="1A1A1A"/>
+                </a:solidFill>
+                <a:latin typeface="Malgun Gothic"/>
+                <a:ea typeface="Malgun Gothic"/>
+                <a:cs typeface="Malgun Gothic"/>
+              </a:defRPr>
+            </a:lvl1pPr>
+          </a:lstStyle>
+          <a:p>
+            <a:fld id="{C1FF6DA9-008F-8B48-92A6-B652298478BF}" type="slidenum">
               <a:rPr lang="en-US" smtClean="0"/>
               <a:t>‹#›</a:t>
             </a:fld>
@@ -365,7 +309,7 @@
     </p:spTree>
     <p:extLst>
       <p:ext uri="{BB962C8B-B14F-4D97-AF65-F5344CB8AC3E}">
-        <p14:creationId xmlns:p14="http://schemas.microsoft.com/office/powerpoint/2010/main" val="1444357513"/>
+        <p14:creationId xmlns:p14="http://schemas.microsoft.com/office/powerpoint/2010/main" val="3168075583"/>
       </p:ext>
     </p:extLst>
   </p:cSld>
@@ -405,12 +349,24 @@
         <p:spPr/>
         <p:txBody>
           <a:bodyPr/>
-          <a:lstStyle/>
-          <a:p>
-            <a:r>
-              <a:rPr lang="en-US"/>
+          <a:lstStyle>
+            <a:lvl1pPr>
+              <a:defRPr sz="2700" b="1">
+                <a:solidFill>
+                  <a:srgbClr val="977A0E"/>
+                </a:solidFill>
+                <a:latin typeface="Malgun Gothic"/>
+                <a:ea typeface="Malgun Gothic"/>
+                <a:cs typeface="Malgun Gothic"/>
+              </a:defRPr>
+            </a:lvl1pPr>
+          </a:lstStyle>
+          <a:p>
+            <a:r>
+              <a:rPr lang="en-US" smtClean="0"/>
               <a:t>Click to edit Master title style</a:t>
             </a:r>
+            <a:endParaRPr lang="en-US"/>
           </a:p>
         </p:txBody>
       </p:sp>
@@ -427,41 +383,53 @@
         <p:spPr/>
         <p:txBody>
           <a:bodyPr vert="eaVert"/>
-          <a:lstStyle/>
+          <a:lstStyle>
+            <a:lvl1pPr>
+              <a:defRPr sz="950">
+                <a:solidFill>
+                  <a:srgbClr val="1A1A1A"/>
+                </a:solidFill>
+                <a:latin typeface="Malgun Gothic"/>
+                <a:ea typeface="Malgun Gothic"/>
+                <a:cs typeface="Malgun Gothic"/>
+              </a:defRPr>
+            </a:lvl1pPr>
+          </a:lstStyle>
           <a:p>
             <a:pPr lvl="0"/>
             <a:r>
-              <a:rPr lang="en-US"/>
+              <a:rPr lang="en-US" smtClean="0"/>
               <a:t>Click to edit Master text styles</a:t>
             </a:r>
           </a:p>
           <a:p>
             <a:pPr lvl="1"/>
             <a:r>
-              <a:rPr lang="en-US"/>
+              <a:rPr lang="en-US" smtClean="0"/>
               <a:t>Second level</a:t>
             </a:r>
           </a:p>
           <a:p>
             <a:pPr lvl="2"/>
             <a:r>
-              <a:rPr lang="en-US"/>
+              <a:rPr lang="en-US" smtClean="0"/>
               <a:t>Third level</a:t>
             </a:r>
           </a:p>
           <a:p>
             <a:pPr lvl="3"/>
             <a:r>
-              <a:rPr lang="en-US"/>
+              <a:rPr lang="en-US" smtClean="0"/>
               <a:t>Fourth level</a:t>
             </a:r>
           </a:p>
           <a:p>
             <a:pPr lvl="4"/>
             <a:r>
-              <a:rPr lang="en-US"/>
+              <a:rPr lang="en-US" smtClean="0"/>
               <a:t>Fifth level</a:t>
             </a:r>
+            <a:endParaRPr lang="en-US"/>
           </a:p>
         </p:txBody>
       </p:sp>
@@ -478,11 +446,22 @@
         <p:spPr/>
         <p:txBody>
           <a:bodyPr/>
-          <a:lstStyle/>
-          <a:p>
-            <a:fld id="{241EB5C9-1307-BA42-ABA2-0BC069CD8E7F}" type="datetimeFigureOut">
-              <a:rPr lang="en-US" smtClean="0"/>
-              <a:t>1/2/22</a:t>
+          <a:lstStyle>
+            <a:lvl1pPr>
+              <a:defRPr sz="950">
+                <a:solidFill>
+                  <a:srgbClr val="1A1A1A"/>
+                </a:solidFill>
+                <a:latin typeface="Malgun Gothic"/>
+                <a:ea typeface="Malgun Gothic"/>
+                <a:cs typeface="Malgun Gothic"/>
+              </a:defRPr>
+            </a:lvl1pPr>
+          </a:lstStyle>
+          <a:p>
+            <a:fld id="{5BCAD085-E8A6-8845-BD4E-CB4CCA059FC4}" type="datetimeFigureOut">
+              <a:rPr lang="en-US" smtClean="0"/>
+              <a:t>1/27/13</a:t>
             </a:fld>
             <a:endParaRPr lang="en-US"/>
           </a:p>
@@ -501,7 +480,18 @@
         <p:spPr/>
         <p:txBody>
           <a:bodyPr/>
-          <a:lstStyle/>
+          <a:lstStyle>
+            <a:lvl1pPr>
+              <a:defRPr sz="950">
+                <a:solidFill>
+                  <a:srgbClr val="1A1A1A"/>
+                </a:solidFill>
+                <a:latin typeface="Malgun Gothic"/>
+                <a:ea typeface="Malgun Gothic"/>
+                <a:cs typeface="Malgun Gothic"/>
+              </a:defRPr>
+            </a:lvl1pPr>
+          </a:lstStyle>
           <a:p>
             <a:endParaRPr lang="en-US"/>
           </a:p>
@@ -520,9 +510,20 @@
         <p:spPr/>
         <p:txBody>
           <a:bodyPr/>
-          <a:lstStyle/>
-          <a:p>
-            <a:fld id="{C5EF2332-01BF-834F-8236-50238282D533}" type="slidenum">
+          <a:lstStyle>
+            <a:lvl1pPr>
+              <a:defRPr sz="950">
+                <a:solidFill>
+                  <a:srgbClr val="1A1A1A"/>
+                </a:solidFill>
+                <a:latin typeface="Malgun Gothic"/>
+                <a:ea typeface="Malgun Gothic"/>
+                <a:cs typeface="Malgun Gothic"/>
+              </a:defRPr>
+            </a:lvl1pPr>
+          </a:lstStyle>
+          <a:p>
+            <a:fld id="{C1FF6DA9-008F-8B48-92A6-B652298478BF}" type="slidenum">
               <a:rPr lang="en-US" smtClean="0"/>
               <a:t>‹#›</a:t>
             </a:fld>
@@ -533,7 +534,7 @@
     </p:spTree>
     <p:extLst>
       <p:ext uri="{BB962C8B-B14F-4D97-AF65-F5344CB8AC3E}">
-        <p14:creationId xmlns:p14="http://schemas.microsoft.com/office/powerpoint/2010/main" val="313914798"/>
+        <p14:creationId xmlns:p14="http://schemas.microsoft.com/office/powerpoint/2010/main" val="2910927964"/>
       </p:ext>
     </p:extLst>
   </p:cSld>
@@ -572,18 +573,30 @@
         </p:nvSpPr>
         <p:spPr>
           <a:xfrm>
-            <a:off x="6629400" y="205979"/>
-            <a:ext cx="2057400" cy="4388644"/>
+            <a:off x="6629400" y="274638"/>
+            <a:ext cx="2057400" cy="5851525"/>
           </a:xfrm>
         </p:spPr>
         <p:txBody>
           <a:bodyPr vert="eaVert"/>
-          <a:lstStyle/>
-          <a:p>
-            <a:r>
-              <a:rPr lang="en-US"/>
+          <a:lstStyle>
+            <a:lvl1pPr>
+              <a:defRPr sz="2700" b="1">
+                <a:solidFill>
+                  <a:srgbClr val="977A0E"/>
+                </a:solidFill>
+                <a:latin typeface="Malgun Gothic"/>
+                <a:ea typeface="Malgun Gothic"/>
+                <a:cs typeface="Malgun Gothic"/>
+              </a:defRPr>
+            </a:lvl1pPr>
+          </a:lstStyle>
+          <a:p>
+            <a:r>
+              <a:rPr lang="en-US" smtClean="0"/>
               <a:t>Click to edit Master title style</a:t>
             </a:r>
+            <a:endParaRPr lang="en-US"/>
           </a:p>
         </p:txBody>
       </p:sp>
@@ -599,47 +612,59 @@
         </p:nvSpPr>
         <p:spPr>
           <a:xfrm>
-            <a:off x="457200" y="205979"/>
-            <a:ext cx="6019800" cy="4388644"/>
+            <a:off x="457200" y="274638"/>
+            <a:ext cx="6019800" cy="5851525"/>
           </a:xfrm>
         </p:spPr>
         <p:txBody>
           <a:bodyPr vert="eaVert"/>
-          <a:lstStyle/>
+          <a:lstStyle>
+            <a:lvl1pPr>
+              <a:defRPr sz="950">
+                <a:solidFill>
+                  <a:srgbClr val="1A1A1A"/>
+                </a:solidFill>
+                <a:latin typeface="Malgun Gothic"/>
+                <a:ea typeface="Malgun Gothic"/>
+                <a:cs typeface="Malgun Gothic"/>
+              </a:defRPr>
+            </a:lvl1pPr>
+          </a:lstStyle>
           <a:p>
             <a:pPr lvl="0"/>
             <a:r>
-              <a:rPr lang="en-US"/>
+              <a:rPr lang="en-US" smtClean="0"/>
               <a:t>Click to edit Master text styles</a:t>
             </a:r>
           </a:p>
           <a:p>
             <a:pPr lvl="1"/>
             <a:r>
-              <a:rPr lang="en-US"/>
+              <a:rPr lang="en-US" smtClean="0"/>
               <a:t>Second level</a:t>
             </a:r>
           </a:p>
           <a:p>
             <a:pPr lvl="2"/>
             <a:r>
-              <a:rPr lang="en-US"/>
+              <a:rPr lang="en-US" smtClean="0"/>
               <a:t>Third level</a:t>
             </a:r>
           </a:p>
           <a:p>
             <a:pPr lvl="3"/>
             <a:r>
-              <a:rPr lang="en-US"/>
+              <a:rPr lang="en-US" smtClean="0"/>
               <a:t>Fourth level</a:t>
             </a:r>
           </a:p>
           <a:p>
             <a:pPr lvl="4"/>
             <a:r>
-              <a:rPr lang="en-US"/>
+              <a:rPr lang="en-US" smtClean="0"/>
               <a:t>Fifth level</a:t>
             </a:r>
+            <a:endParaRPr lang="en-US"/>
           </a:p>
         </p:txBody>
       </p:sp>
@@ -656,11 +681,22 @@
         <p:spPr/>
         <p:txBody>
           <a:bodyPr/>
-          <a:lstStyle/>
-          <a:p>
-            <a:fld id="{241EB5C9-1307-BA42-ABA2-0BC069CD8E7F}" type="datetimeFigureOut">
-              <a:rPr lang="en-US" smtClean="0"/>
-              <a:t>1/2/22</a:t>
+          <a:lstStyle>
+            <a:lvl1pPr>
+              <a:defRPr sz="950">
+                <a:solidFill>
+                  <a:srgbClr val="1A1A1A"/>
+                </a:solidFill>
+                <a:latin typeface="Malgun Gothic"/>
+                <a:ea typeface="Malgun Gothic"/>
+                <a:cs typeface="Malgun Gothic"/>
+              </a:defRPr>
+            </a:lvl1pPr>
+          </a:lstStyle>
+          <a:p>
+            <a:fld id="{5BCAD085-E8A6-8845-BD4E-CB4CCA059FC4}" type="datetimeFigureOut">
+              <a:rPr lang="en-US" smtClean="0"/>
+              <a:t>1/27/13</a:t>
             </a:fld>
             <a:endParaRPr lang="en-US"/>
           </a:p>
@@ -679,7 +715,18 @@
         <p:spPr/>
         <p:txBody>
           <a:bodyPr/>
-          <a:lstStyle/>
+          <a:lstStyle>
+            <a:lvl1pPr>
+              <a:defRPr sz="950">
+                <a:solidFill>
+                  <a:srgbClr val="1A1A1A"/>
+                </a:solidFill>
+                <a:latin typeface="Malgun Gothic"/>
+                <a:ea typeface="Malgun Gothic"/>
+                <a:cs typeface="Malgun Gothic"/>
+              </a:defRPr>
+            </a:lvl1pPr>
+          </a:lstStyle>
           <a:p>
             <a:endParaRPr lang="en-US"/>
           </a:p>
@@ -698,9 +745,20 @@
         <p:spPr/>
         <p:txBody>
           <a:bodyPr/>
-          <a:lstStyle/>
-          <a:p>
-            <a:fld id="{C5EF2332-01BF-834F-8236-50238282D533}" type="slidenum">
+          <a:lstStyle>
+            <a:lvl1pPr>
+              <a:defRPr sz="950">
+                <a:solidFill>
+                  <a:srgbClr val="1A1A1A"/>
+                </a:solidFill>
+                <a:latin typeface="Malgun Gothic"/>
+                <a:ea typeface="Malgun Gothic"/>
+                <a:cs typeface="Malgun Gothic"/>
+              </a:defRPr>
+            </a:lvl1pPr>
+          </a:lstStyle>
+          <a:p>
+            <a:fld id="{C1FF6DA9-008F-8B48-92A6-B652298478BF}" type="slidenum">
               <a:rPr lang="en-US" smtClean="0"/>
               <a:t>‹#›</a:t>
             </a:fld>
@@ -711,7 +769,7 @@
     </p:spTree>
     <p:extLst>
       <p:ext uri="{BB962C8B-B14F-4D97-AF65-F5344CB8AC3E}">
-        <p14:creationId xmlns:p14="http://schemas.microsoft.com/office/powerpoint/2010/main" val="2581529045"/>
+        <p14:creationId xmlns:p14="http://schemas.microsoft.com/office/powerpoint/2010/main" val="3612223792"/>
       </p:ext>
     </p:extLst>
   </p:cSld>
@@ -751,12 +809,24 @@
         <p:spPr/>
         <p:txBody>
           <a:bodyPr/>
-          <a:lstStyle/>
-          <a:p>
-            <a:r>
-              <a:rPr lang="en-US"/>
+          <a:lstStyle>
+            <a:lvl1pPr>
+              <a:defRPr sz="2700" b="1">
+                <a:solidFill>
+                  <a:srgbClr val="977A0E"/>
+                </a:solidFill>
+                <a:latin typeface="Malgun Gothic"/>
+                <a:ea typeface="Malgun Gothic"/>
+                <a:cs typeface="Malgun Gothic"/>
+              </a:defRPr>
+            </a:lvl1pPr>
+          </a:lstStyle>
+          <a:p>
+            <a:r>
+              <a:rPr lang="en-US" smtClean="0"/>
               <a:t>Click to edit Master title style</a:t>
             </a:r>
+            <a:endParaRPr lang="en-US"/>
           </a:p>
         </p:txBody>
       </p:sp>
@@ -773,41 +843,53 @@
         <p:spPr/>
         <p:txBody>
           <a:bodyPr/>
-          <a:lstStyle/>
+          <a:lstStyle>
+            <a:lvl1pPr>
+              <a:defRPr sz="950">
+                <a:solidFill>
+                  <a:srgbClr val="1A1A1A"/>
+                </a:solidFill>
+                <a:latin typeface="Malgun Gothic"/>
+                <a:ea typeface="Malgun Gothic"/>
+                <a:cs typeface="Malgun Gothic"/>
+              </a:defRPr>
+            </a:lvl1pPr>
+          </a:lstStyle>
           <a:p>
             <a:pPr lvl="0"/>
             <a:r>
-              <a:rPr lang="en-US"/>
+              <a:rPr lang="en-US" smtClean="0"/>
               <a:t>Click to edit Master text styles</a:t>
             </a:r>
           </a:p>
           <a:p>
             <a:pPr lvl="1"/>
             <a:r>
-              <a:rPr lang="en-US"/>
+              <a:rPr lang="en-US" smtClean="0"/>
               <a:t>Second level</a:t>
             </a:r>
           </a:p>
           <a:p>
             <a:pPr lvl="2"/>
             <a:r>
-              <a:rPr lang="en-US"/>
+              <a:rPr lang="en-US" smtClean="0"/>
               <a:t>Third level</a:t>
             </a:r>
           </a:p>
           <a:p>
             <a:pPr lvl="3"/>
             <a:r>
-              <a:rPr lang="en-US"/>
+              <a:rPr lang="en-US" smtClean="0"/>
               <a:t>Fourth level</a:t>
             </a:r>
           </a:p>
           <a:p>
             <a:pPr lvl="4"/>
             <a:r>
-              <a:rPr lang="en-US"/>
+              <a:rPr lang="en-US" smtClean="0"/>
               <a:t>Fifth level</a:t>
             </a:r>
+            <a:endParaRPr lang="en-US"/>
           </a:p>
         </p:txBody>
       </p:sp>
@@ -824,11 +906,22 @@
         <p:spPr/>
         <p:txBody>
           <a:bodyPr/>
-          <a:lstStyle/>
-          <a:p>
-            <a:fld id="{241EB5C9-1307-BA42-ABA2-0BC069CD8E7F}" type="datetimeFigureOut">
-              <a:rPr lang="en-US" smtClean="0"/>
-              <a:t>1/2/22</a:t>
+          <a:lstStyle>
+            <a:lvl1pPr>
+              <a:defRPr sz="950">
+                <a:solidFill>
+                  <a:srgbClr val="1A1A1A"/>
+                </a:solidFill>
+                <a:latin typeface="Malgun Gothic"/>
+                <a:ea typeface="Malgun Gothic"/>
+                <a:cs typeface="Malgun Gothic"/>
+              </a:defRPr>
+            </a:lvl1pPr>
+          </a:lstStyle>
+          <a:p>
+            <a:fld id="{5BCAD085-E8A6-8845-BD4E-CB4CCA059FC4}" type="datetimeFigureOut">
+              <a:rPr lang="en-US" smtClean="0"/>
+              <a:t>1/27/13</a:t>
             </a:fld>
             <a:endParaRPr lang="en-US"/>
           </a:p>
@@ -847,7 +940,18 @@
         <p:spPr/>
         <p:txBody>
           <a:bodyPr/>
-          <a:lstStyle/>
+          <a:lstStyle>
+            <a:lvl1pPr>
+              <a:defRPr sz="950">
+                <a:solidFill>
+                  <a:srgbClr val="1A1A1A"/>
+                </a:solidFill>
+                <a:latin typeface="Malgun Gothic"/>
+                <a:ea typeface="Malgun Gothic"/>
+                <a:cs typeface="Malgun Gothic"/>
+              </a:defRPr>
+            </a:lvl1pPr>
+          </a:lstStyle>
           <a:p>
             <a:endParaRPr lang="en-US"/>
           </a:p>
@@ -866,9 +970,20 @@
         <p:spPr/>
         <p:txBody>
           <a:bodyPr/>
-          <a:lstStyle/>
-          <a:p>
-            <a:fld id="{C5EF2332-01BF-834F-8236-50238282D533}" type="slidenum">
+          <a:lstStyle>
+            <a:lvl1pPr>
+              <a:defRPr sz="950">
+                <a:solidFill>
+                  <a:srgbClr val="1A1A1A"/>
+                </a:solidFill>
+                <a:latin typeface="Malgun Gothic"/>
+                <a:ea typeface="Malgun Gothic"/>
+                <a:cs typeface="Malgun Gothic"/>
+              </a:defRPr>
+            </a:lvl1pPr>
+          </a:lstStyle>
+          <a:p>
+            <a:fld id="{C1FF6DA9-008F-8B48-92A6-B652298478BF}" type="slidenum">
               <a:rPr lang="en-US" smtClean="0"/>
               <a:t>‹#›</a:t>
             </a:fld>
@@ -879,7 +994,7 @@
     </p:spTree>
     <p:extLst>
       <p:ext uri="{BB962C8B-B14F-4D97-AF65-F5344CB8AC3E}">
-        <p14:creationId xmlns:p14="http://schemas.microsoft.com/office/powerpoint/2010/main" val="338346009"/>
+        <p14:creationId xmlns:p14="http://schemas.microsoft.com/office/powerpoint/2010/main" val="2614314258"/>
       </p:ext>
     </p:extLst>
   </p:cSld>
@@ -918,22 +1033,30 @@
         </p:nvSpPr>
         <p:spPr>
           <a:xfrm>
-            <a:off x="722313" y="3305176"/>
-            <a:ext cx="7772400" cy="1021556"/>
+            <a:off x="722313" y="4406900"/>
+            <a:ext cx="7772400" cy="1362075"/>
           </a:xfrm>
         </p:spPr>
         <p:txBody>
           <a:bodyPr anchor="t"/>
           <a:lstStyle>
-            <a:lvl1pPr algn="l">
-              <a:defRPr sz="3000" b="1" cap="all"/>
-            </a:lvl1pPr>
-          </a:lstStyle>
-          <a:p>
-            <a:r>
-              <a:rPr lang="en-US"/>
+            <a:lvl1pPr>
+              <a:defRPr sz="2700" b="1">
+                <a:solidFill>
+                  <a:srgbClr val="977A0E"/>
+                </a:solidFill>
+                <a:latin typeface="Malgun Gothic"/>
+                <a:ea typeface="Malgun Gothic"/>
+                <a:cs typeface="Malgun Gothic"/>
+              </a:defRPr>
+            </a:lvl1pPr>
+          </a:lstStyle>
+          <a:p>
+            <a:r>
+              <a:rPr lang="en-US" smtClean="0"/>
               <a:t>Click to edit Master title style</a:t>
             </a:r>
+            <a:endParaRPr lang="en-US"/>
           </a:p>
         </p:txBody>
       </p:sp>
@@ -949,108 +1072,28 @@
         </p:nvSpPr>
         <p:spPr>
           <a:xfrm>
-            <a:off x="722313" y="2180035"/>
-            <a:ext cx="7772400" cy="1125140"/>
+            <a:off x="722313" y="2906713"/>
+            <a:ext cx="7772400" cy="1500187"/>
           </a:xfrm>
         </p:spPr>
         <p:txBody>
           <a:bodyPr anchor="b"/>
           <a:lstStyle>
-            <a:lvl1pPr marL="0" indent="0">
-              <a:buNone/>
-              <a:defRPr sz="1500">
-                <a:solidFill>
-                  <a:schemeClr val="tx1">
-                    <a:tint val="75000"/>
-                  </a:schemeClr>
-                </a:solidFill>
-              </a:defRPr>
-            </a:lvl1pPr>
-            <a:lvl2pPr marL="342900" indent="0">
-              <a:buNone/>
-              <a:defRPr sz="1350">
-                <a:solidFill>
-                  <a:schemeClr val="tx1">
-                    <a:tint val="75000"/>
-                  </a:schemeClr>
-                </a:solidFill>
-              </a:defRPr>
-            </a:lvl2pPr>
-            <a:lvl3pPr marL="685800" indent="0">
-              <a:buNone/>
-              <a:defRPr sz="1200">
-                <a:solidFill>
-                  <a:schemeClr val="tx1">
-                    <a:tint val="75000"/>
-                  </a:schemeClr>
-                </a:solidFill>
-              </a:defRPr>
-            </a:lvl3pPr>
-            <a:lvl4pPr marL="1028700" indent="0">
-              <a:buNone/>
-              <a:defRPr sz="1050">
-                <a:solidFill>
-                  <a:schemeClr val="tx1">
-                    <a:tint val="75000"/>
-                  </a:schemeClr>
-                </a:solidFill>
-              </a:defRPr>
-            </a:lvl4pPr>
-            <a:lvl5pPr marL="1371600" indent="0">
-              <a:buNone/>
-              <a:defRPr sz="1050">
-                <a:solidFill>
-                  <a:schemeClr val="tx1">
-                    <a:tint val="75000"/>
-                  </a:schemeClr>
-                </a:solidFill>
-              </a:defRPr>
-            </a:lvl5pPr>
-            <a:lvl6pPr marL="1714500" indent="0">
-              <a:buNone/>
-              <a:defRPr sz="1050">
-                <a:solidFill>
-                  <a:schemeClr val="tx1">
-                    <a:tint val="75000"/>
-                  </a:schemeClr>
-                </a:solidFill>
-              </a:defRPr>
-            </a:lvl6pPr>
-            <a:lvl7pPr marL="2057400" indent="0">
-              <a:buNone/>
-              <a:defRPr sz="1050">
-                <a:solidFill>
-                  <a:schemeClr val="tx1">
-                    <a:tint val="75000"/>
-                  </a:schemeClr>
-                </a:solidFill>
-              </a:defRPr>
-            </a:lvl7pPr>
-            <a:lvl8pPr marL="2400300" indent="0">
-              <a:buNone/>
-              <a:defRPr sz="1050">
-                <a:solidFill>
-                  <a:schemeClr val="tx1">
-                    <a:tint val="75000"/>
-                  </a:schemeClr>
-                </a:solidFill>
-              </a:defRPr>
-            </a:lvl8pPr>
-            <a:lvl9pPr marL="2743200" indent="0">
-              <a:buNone/>
-              <a:defRPr sz="1050">
-                <a:solidFill>
-                  <a:schemeClr val="tx1">
-                    <a:tint val="75000"/>
-                  </a:schemeClr>
-                </a:solidFill>
-              </a:defRPr>
-            </a:lvl9pPr>
+            <a:lvl1pPr>
+              <a:defRPr sz="950">
+                <a:solidFill>
+                  <a:srgbClr val="1A1A1A"/>
+                </a:solidFill>
+                <a:latin typeface="Malgun Gothic"/>
+                <a:ea typeface="Malgun Gothic"/>
+                <a:cs typeface="Malgun Gothic"/>
+              </a:defRPr>
+            </a:lvl1pPr>
           </a:lstStyle>
           <a:p>
             <a:pPr lvl="0"/>
             <a:r>
-              <a:rPr lang="en-US"/>
+              <a:rPr lang="en-US" smtClean="0"/>
               <a:t>Click to edit Master text styles</a:t>
             </a:r>
           </a:p>
@@ -1069,11 +1112,22 @@
         <p:spPr/>
         <p:txBody>
           <a:bodyPr/>
-          <a:lstStyle/>
-          <a:p>
-            <a:fld id="{241EB5C9-1307-BA42-ABA2-0BC069CD8E7F}" type="datetimeFigureOut">
-              <a:rPr lang="en-US" smtClean="0"/>
-              <a:t>1/2/22</a:t>
+          <a:lstStyle>
+            <a:lvl1pPr>
+              <a:defRPr sz="950">
+                <a:solidFill>
+                  <a:srgbClr val="1A1A1A"/>
+                </a:solidFill>
+                <a:latin typeface="Malgun Gothic"/>
+                <a:ea typeface="Malgun Gothic"/>
+                <a:cs typeface="Malgun Gothic"/>
+              </a:defRPr>
+            </a:lvl1pPr>
+          </a:lstStyle>
+          <a:p>
+            <a:fld id="{5BCAD085-E8A6-8845-BD4E-CB4CCA059FC4}" type="datetimeFigureOut">
+              <a:rPr lang="en-US" smtClean="0"/>
+              <a:t>1/27/13</a:t>
             </a:fld>
             <a:endParaRPr lang="en-US"/>
           </a:p>
@@ -1092,7 +1146,18 @@
         <p:spPr/>
         <p:txBody>
           <a:bodyPr/>
-          <a:lstStyle/>
+          <a:lstStyle>
+            <a:lvl1pPr>
+              <a:defRPr sz="950">
+                <a:solidFill>
+                  <a:srgbClr val="1A1A1A"/>
+                </a:solidFill>
+                <a:latin typeface="Malgun Gothic"/>
+                <a:ea typeface="Malgun Gothic"/>
+                <a:cs typeface="Malgun Gothic"/>
+              </a:defRPr>
+            </a:lvl1pPr>
+          </a:lstStyle>
           <a:p>
             <a:endParaRPr lang="en-US"/>
           </a:p>
@@ -1111,9 +1176,20 @@
         <p:spPr/>
         <p:txBody>
           <a:bodyPr/>
-          <a:lstStyle/>
-          <a:p>
-            <a:fld id="{C5EF2332-01BF-834F-8236-50238282D533}" type="slidenum">
+          <a:lstStyle>
+            <a:lvl1pPr>
+              <a:defRPr sz="950">
+                <a:solidFill>
+                  <a:srgbClr val="1A1A1A"/>
+                </a:solidFill>
+                <a:latin typeface="Malgun Gothic"/>
+                <a:ea typeface="Malgun Gothic"/>
+                <a:cs typeface="Malgun Gothic"/>
+              </a:defRPr>
+            </a:lvl1pPr>
+          </a:lstStyle>
+          <a:p>
+            <a:fld id="{C1FF6DA9-008F-8B48-92A6-B652298478BF}" type="slidenum">
               <a:rPr lang="en-US" smtClean="0"/>
               <a:t>‹#›</a:t>
             </a:fld>
@@ -1124,7 +1200,7 @@
     </p:spTree>
     <p:extLst>
       <p:ext uri="{BB962C8B-B14F-4D97-AF65-F5344CB8AC3E}">
-        <p14:creationId xmlns:p14="http://schemas.microsoft.com/office/powerpoint/2010/main" val="1073069076"/>
+        <p14:creationId xmlns:p14="http://schemas.microsoft.com/office/powerpoint/2010/main" val="960648375"/>
       </p:ext>
     </p:extLst>
   </p:cSld>
@@ -1164,12 +1240,24 @@
         <p:spPr/>
         <p:txBody>
           <a:bodyPr/>
-          <a:lstStyle/>
-          <a:p>
-            <a:r>
-              <a:rPr lang="en-US"/>
+          <a:lstStyle>
+            <a:lvl1pPr>
+              <a:defRPr sz="2700" b="1">
+                <a:solidFill>
+                  <a:srgbClr val="977A0E"/>
+                </a:solidFill>
+                <a:latin typeface="Malgun Gothic"/>
+                <a:ea typeface="Malgun Gothic"/>
+                <a:cs typeface="Malgun Gothic"/>
+              </a:defRPr>
+            </a:lvl1pPr>
+          </a:lstStyle>
+          <a:p>
+            <a:r>
+              <a:rPr lang="en-US" smtClean="0"/>
               <a:t>Click to edit Master title style</a:t>
             </a:r>
+            <a:endParaRPr lang="en-US"/>
           </a:p>
         </p:txBody>
       </p:sp>
@@ -1185,75 +1273,59 @@
         </p:nvSpPr>
         <p:spPr>
           <a:xfrm>
-            <a:off x="457200" y="1200151"/>
-            <a:ext cx="4038600" cy="3394472"/>
+            <a:off x="457200" y="1600200"/>
+            <a:ext cx="4038600" cy="4525963"/>
           </a:xfrm>
         </p:spPr>
         <p:txBody>
           <a:bodyPr/>
           <a:lstStyle>
             <a:lvl1pPr>
-              <a:defRPr sz="2100"/>
-            </a:lvl1pPr>
-            <a:lvl2pPr>
-              <a:defRPr sz="1800"/>
-            </a:lvl2pPr>
-            <a:lvl3pPr>
-              <a:defRPr sz="1500"/>
-            </a:lvl3pPr>
-            <a:lvl4pPr>
-              <a:defRPr sz="1350"/>
-            </a:lvl4pPr>
-            <a:lvl5pPr>
-              <a:defRPr sz="1350"/>
-            </a:lvl5pPr>
-            <a:lvl6pPr>
-              <a:defRPr sz="1350"/>
-            </a:lvl6pPr>
-            <a:lvl7pPr>
-              <a:defRPr sz="1350"/>
-            </a:lvl7pPr>
-            <a:lvl8pPr>
-              <a:defRPr sz="1350"/>
-            </a:lvl8pPr>
-            <a:lvl9pPr>
-              <a:defRPr sz="1350"/>
-            </a:lvl9pPr>
+              <a:defRPr sz="950">
+                <a:solidFill>
+                  <a:srgbClr val="1A1A1A"/>
+                </a:solidFill>
+                <a:latin typeface="Malgun Gothic"/>
+                <a:ea typeface="Malgun Gothic"/>
+                <a:cs typeface="Malgun Gothic"/>
+              </a:defRPr>
+            </a:lvl1pPr>
           </a:lstStyle>
           <a:p>
             <a:pPr lvl="0"/>
             <a:r>
-              <a:rPr lang="en-US"/>
+              <a:rPr lang="en-US" smtClean="0"/>
               <a:t>Click to edit Master text styles</a:t>
             </a:r>
           </a:p>
           <a:p>
             <a:pPr lvl="1"/>
             <a:r>
-              <a:rPr lang="en-US"/>
+              <a:rPr lang="en-US" smtClean="0"/>
               <a:t>Second level</a:t>
             </a:r>
           </a:p>
           <a:p>
             <a:pPr lvl="2"/>
             <a:r>
-              <a:rPr lang="en-US"/>
+              <a:rPr lang="en-US" smtClean="0"/>
               <a:t>Third level</a:t>
             </a:r>
           </a:p>
           <a:p>
             <a:pPr lvl="3"/>
             <a:r>
-              <a:rPr lang="en-US"/>
+              <a:rPr lang="en-US" smtClean="0"/>
               <a:t>Fourth level</a:t>
             </a:r>
           </a:p>
           <a:p>
             <a:pPr lvl="4"/>
             <a:r>
-              <a:rPr lang="en-US"/>
+              <a:rPr lang="en-US" smtClean="0"/>
               <a:t>Fifth level</a:t>
             </a:r>
+            <a:endParaRPr lang="en-US"/>
           </a:p>
         </p:txBody>
       </p:sp>
@@ -1269,75 +1341,59 @@
         </p:nvSpPr>
         <p:spPr>
           <a:xfrm>
-            <a:off x="4648200" y="1200151"/>
-            <a:ext cx="4038600" cy="3394472"/>
+            <a:off x="4648200" y="1600200"/>
+            <a:ext cx="4038600" cy="4525963"/>
           </a:xfrm>
         </p:spPr>
         <p:txBody>
           <a:bodyPr/>
           <a:lstStyle>
             <a:lvl1pPr>
-              <a:defRPr sz="2100"/>
-            </a:lvl1pPr>
-            <a:lvl2pPr>
-              <a:defRPr sz="1800"/>
-            </a:lvl2pPr>
-            <a:lvl3pPr>
-              <a:defRPr sz="1500"/>
-            </a:lvl3pPr>
-            <a:lvl4pPr>
-              <a:defRPr sz="1350"/>
-            </a:lvl4pPr>
-            <a:lvl5pPr>
-              <a:defRPr sz="1350"/>
-            </a:lvl5pPr>
-            <a:lvl6pPr>
-              <a:defRPr sz="1350"/>
-            </a:lvl6pPr>
-            <a:lvl7pPr>
-              <a:defRPr sz="1350"/>
-            </a:lvl7pPr>
-            <a:lvl8pPr>
-              <a:defRPr sz="1350"/>
-            </a:lvl8pPr>
-            <a:lvl9pPr>
-              <a:defRPr sz="1350"/>
-            </a:lvl9pPr>
+              <a:defRPr sz="950">
+                <a:solidFill>
+                  <a:srgbClr val="1A1A1A"/>
+                </a:solidFill>
+                <a:latin typeface="Malgun Gothic"/>
+                <a:ea typeface="Malgun Gothic"/>
+                <a:cs typeface="Malgun Gothic"/>
+              </a:defRPr>
+            </a:lvl1pPr>
           </a:lstStyle>
           <a:p>
             <a:pPr lvl="0"/>
             <a:r>
-              <a:rPr lang="en-US"/>
+              <a:rPr lang="en-US" smtClean="0"/>
               <a:t>Click to edit Master text styles</a:t>
             </a:r>
           </a:p>
           <a:p>
             <a:pPr lvl="1"/>
             <a:r>
-              <a:rPr lang="en-US"/>
+              <a:rPr lang="en-US" smtClean="0"/>
               <a:t>Second level</a:t>
             </a:r>
           </a:p>
           <a:p>
             <a:pPr lvl="2"/>
             <a:r>
-              <a:rPr lang="en-US"/>
+              <a:rPr lang="en-US" smtClean="0"/>
               <a:t>Third level</a:t>
             </a:r>
           </a:p>
           <a:p>
             <a:pPr lvl="3"/>
             <a:r>
-              <a:rPr lang="en-US"/>
+              <a:rPr lang="en-US" smtClean="0"/>
               <a:t>Fourth level</a:t>
             </a:r>
           </a:p>
           <a:p>
             <a:pPr lvl="4"/>
             <a:r>
-              <a:rPr lang="en-US"/>
+              <a:rPr lang="en-US" smtClean="0"/>
               <a:t>Fifth level</a:t>
             </a:r>
+            <a:endParaRPr lang="en-US"/>
           </a:p>
         </p:txBody>
       </p:sp>
@@ -1354,11 +1410,22 @@
         <p:spPr/>
         <p:txBody>
           <a:bodyPr/>
-          <a:lstStyle/>
-          <a:p>
-            <a:fld id="{241EB5C9-1307-BA42-ABA2-0BC069CD8E7F}" type="datetimeFigureOut">
-              <a:rPr lang="en-US" smtClean="0"/>
-              <a:t>1/2/22</a:t>
+          <a:lstStyle>
+            <a:lvl1pPr>
+              <a:defRPr sz="950">
+                <a:solidFill>
+                  <a:srgbClr val="1A1A1A"/>
+                </a:solidFill>
+                <a:latin typeface="Malgun Gothic"/>
+                <a:ea typeface="Malgun Gothic"/>
+                <a:cs typeface="Malgun Gothic"/>
+              </a:defRPr>
+            </a:lvl1pPr>
+          </a:lstStyle>
+          <a:p>
+            <a:fld id="{5BCAD085-E8A6-8845-BD4E-CB4CCA059FC4}" type="datetimeFigureOut">
+              <a:rPr lang="en-US" smtClean="0"/>
+              <a:t>1/27/13</a:t>
             </a:fld>
             <a:endParaRPr lang="en-US"/>
           </a:p>
@@ -1377,7 +1444,18 @@
         <p:spPr/>
         <p:txBody>
           <a:bodyPr/>
-          <a:lstStyle/>
+          <a:lstStyle>
+            <a:lvl1pPr>
+              <a:defRPr sz="950">
+                <a:solidFill>
+                  <a:srgbClr val="1A1A1A"/>
+                </a:solidFill>
+                <a:latin typeface="Malgun Gothic"/>
+                <a:ea typeface="Malgun Gothic"/>
+                <a:cs typeface="Malgun Gothic"/>
+              </a:defRPr>
+            </a:lvl1pPr>
+          </a:lstStyle>
           <a:p>
             <a:endParaRPr lang="en-US"/>
           </a:p>
@@ -1396,9 +1474,20 @@
         <p:spPr/>
         <p:txBody>
           <a:bodyPr/>
-          <a:lstStyle/>
-          <a:p>
-            <a:fld id="{C5EF2332-01BF-834F-8236-50238282D533}" type="slidenum">
+          <a:lstStyle>
+            <a:lvl1pPr>
+              <a:defRPr sz="950">
+                <a:solidFill>
+                  <a:srgbClr val="1A1A1A"/>
+                </a:solidFill>
+                <a:latin typeface="Malgun Gothic"/>
+                <a:ea typeface="Malgun Gothic"/>
+                <a:cs typeface="Malgun Gothic"/>
+              </a:defRPr>
+            </a:lvl1pPr>
+          </a:lstStyle>
+          <a:p>
+            <a:fld id="{C1FF6DA9-008F-8B48-92A6-B652298478BF}" type="slidenum">
               <a:rPr lang="en-US" smtClean="0"/>
               <a:t>‹#›</a:t>
             </a:fld>
@@ -1409,7 +1498,7 @@
     </p:spTree>
     <p:extLst>
       <p:ext uri="{BB962C8B-B14F-4D97-AF65-F5344CB8AC3E}">
-        <p14:creationId xmlns:p14="http://schemas.microsoft.com/office/powerpoint/2010/main" val="2619886245"/>
+        <p14:creationId xmlns:p14="http://schemas.microsoft.com/office/powerpoint/2010/main" val="2782244947"/>
       </p:ext>
     </p:extLst>
   </p:cSld>
@@ -1451,14 +1540,22 @@
           <a:bodyPr/>
           <a:lstStyle>
             <a:lvl1pPr>
-              <a:defRPr/>
-            </a:lvl1pPr>
-          </a:lstStyle>
-          <a:p>
-            <a:r>
-              <a:rPr lang="en-US"/>
+              <a:defRPr sz="2700" b="1">
+                <a:solidFill>
+                  <a:srgbClr val="977A0E"/>
+                </a:solidFill>
+                <a:latin typeface="Malgun Gothic"/>
+                <a:ea typeface="Malgun Gothic"/>
+                <a:cs typeface="Malgun Gothic"/>
+              </a:defRPr>
+            </a:lvl1pPr>
+          </a:lstStyle>
+          <a:p>
+            <a:r>
+              <a:rPr lang="en-US" smtClean="0"/>
               <a:t>Click to edit Master title style</a:t>
             </a:r>
+            <a:endParaRPr lang="en-US"/>
           </a:p>
         </p:txBody>
       </p:sp>
@@ -1474,54 +1571,28 @@
         </p:nvSpPr>
         <p:spPr>
           <a:xfrm>
-            <a:off x="457200" y="1151335"/>
-            <a:ext cx="4040188" cy="479822"/>
+            <a:off x="457200" y="1535113"/>
+            <a:ext cx="4040188" cy="639762"/>
           </a:xfrm>
         </p:spPr>
         <p:txBody>
           <a:bodyPr anchor="b"/>
           <a:lstStyle>
-            <a:lvl1pPr marL="0" indent="0">
-              <a:buNone/>
-              <a:defRPr sz="1800" b="1"/>
-            </a:lvl1pPr>
-            <a:lvl2pPr marL="342900" indent="0">
-              <a:buNone/>
-              <a:defRPr sz="1500" b="1"/>
-            </a:lvl2pPr>
-            <a:lvl3pPr marL="685800" indent="0">
-              <a:buNone/>
-              <a:defRPr sz="1350" b="1"/>
-            </a:lvl3pPr>
-            <a:lvl4pPr marL="1028700" indent="0">
-              <a:buNone/>
-              <a:defRPr sz="1200" b="1"/>
-            </a:lvl4pPr>
-            <a:lvl5pPr marL="1371600" indent="0">
-              <a:buNone/>
-              <a:defRPr sz="1200" b="1"/>
-            </a:lvl5pPr>
-            <a:lvl6pPr marL="1714500" indent="0">
-              <a:buNone/>
-              <a:defRPr sz="1200" b="1"/>
-            </a:lvl6pPr>
-            <a:lvl7pPr marL="2057400" indent="0">
-              <a:buNone/>
-              <a:defRPr sz="1200" b="1"/>
-            </a:lvl7pPr>
-            <a:lvl8pPr marL="2400300" indent="0">
-              <a:buNone/>
-              <a:defRPr sz="1200" b="1"/>
-            </a:lvl8pPr>
-            <a:lvl9pPr marL="2743200" indent="0">
-              <a:buNone/>
-              <a:defRPr sz="1200" b="1"/>
-            </a:lvl9pPr>
+            <a:lvl1pPr>
+              <a:defRPr sz="950">
+                <a:solidFill>
+                  <a:srgbClr val="1A1A1A"/>
+                </a:solidFill>
+                <a:latin typeface="Malgun Gothic"/>
+                <a:ea typeface="Malgun Gothic"/>
+                <a:cs typeface="Malgun Gothic"/>
+              </a:defRPr>
+            </a:lvl1pPr>
           </a:lstStyle>
           <a:p>
             <a:pPr lvl="0"/>
             <a:r>
-              <a:rPr lang="en-US"/>
+              <a:rPr lang="en-US" smtClean="0"/>
               <a:t>Click to edit Master text styles</a:t>
             </a:r>
           </a:p>
@@ -1539,75 +1610,59 @@
         </p:nvSpPr>
         <p:spPr>
           <a:xfrm>
-            <a:off x="457200" y="1631156"/>
-            <a:ext cx="4040188" cy="2963466"/>
+            <a:off x="457200" y="2174875"/>
+            <a:ext cx="4040188" cy="3951288"/>
           </a:xfrm>
         </p:spPr>
         <p:txBody>
           <a:bodyPr/>
           <a:lstStyle>
             <a:lvl1pPr>
-              <a:defRPr sz="1800"/>
-            </a:lvl1pPr>
-            <a:lvl2pPr>
-              <a:defRPr sz="1500"/>
-            </a:lvl2pPr>
-            <a:lvl3pPr>
-              <a:defRPr sz="1350"/>
-            </a:lvl3pPr>
-            <a:lvl4pPr>
-              <a:defRPr sz="1200"/>
-            </a:lvl4pPr>
-            <a:lvl5pPr>
-              <a:defRPr sz="1200"/>
-            </a:lvl5pPr>
-            <a:lvl6pPr>
-              <a:defRPr sz="1200"/>
-            </a:lvl6pPr>
-            <a:lvl7pPr>
-              <a:defRPr sz="1200"/>
-            </a:lvl7pPr>
-            <a:lvl8pPr>
-              <a:defRPr sz="1200"/>
-            </a:lvl8pPr>
-            <a:lvl9pPr>
-              <a:defRPr sz="1200"/>
-            </a:lvl9pPr>
+              <a:defRPr sz="950">
+                <a:solidFill>
+                  <a:srgbClr val="1A1A1A"/>
+                </a:solidFill>
+                <a:latin typeface="Malgun Gothic"/>
+                <a:ea typeface="Malgun Gothic"/>
+                <a:cs typeface="Malgun Gothic"/>
+              </a:defRPr>
+            </a:lvl1pPr>
           </a:lstStyle>
           <a:p>
             <a:pPr lvl="0"/>
             <a:r>
-              <a:rPr lang="en-US"/>
+              <a:rPr lang="en-US" smtClean="0"/>
               <a:t>Click to edit Master text styles</a:t>
             </a:r>
           </a:p>
           <a:p>
             <a:pPr lvl="1"/>
             <a:r>
-              <a:rPr lang="en-US"/>
+              <a:rPr lang="en-US" smtClean="0"/>
               <a:t>Second level</a:t>
             </a:r>
           </a:p>
           <a:p>
             <a:pPr lvl="2"/>
             <a:r>
-              <a:rPr lang="en-US"/>
+              <a:rPr lang="en-US" smtClean="0"/>
               <a:t>Third level</a:t>
             </a:r>
           </a:p>
           <a:p>
             <a:pPr lvl="3"/>
             <a:r>
-              <a:rPr lang="en-US"/>
+              <a:rPr lang="en-US" smtClean="0"/>
               <a:t>Fourth level</a:t>
             </a:r>
           </a:p>
           <a:p>
             <a:pPr lvl="4"/>
             <a:r>
-              <a:rPr lang="en-US"/>
+              <a:rPr lang="en-US" smtClean="0"/>
               <a:t>Fifth level</a:t>
             </a:r>
+            <a:endParaRPr lang="en-US"/>
           </a:p>
         </p:txBody>
       </p:sp>
@@ -1623,54 +1678,28 @@
         </p:nvSpPr>
         <p:spPr>
           <a:xfrm>
-            <a:off x="4645026" y="1151335"/>
-            <a:ext cx="4041775" cy="479822"/>
+            <a:off x="4645025" y="1535113"/>
+            <a:ext cx="4041775" cy="639762"/>
           </a:xfrm>
         </p:spPr>
         <p:txBody>
           <a:bodyPr anchor="b"/>
           <a:lstStyle>
-            <a:lvl1pPr marL="0" indent="0">
-              <a:buNone/>
-              <a:defRPr sz="1800" b="1"/>
-            </a:lvl1pPr>
-            <a:lvl2pPr marL="342900" indent="0">
-              <a:buNone/>
-              <a:defRPr sz="1500" b="1"/>
-            </a:lvl2pPr>
-            <a:lvl3pPr marL="685800" indent="0">
-              <a:buNone/>
-              <a:defRPr sz="1350" b="1"/>
-            </a:lvl3pPr>
-            <a:lvl4pPr marL="1028700" indent="0">
-              <a:buNone/>
-              <a:defRPr sz="1200" b="1"/>
-            </a:lvl4pPr>
-            <a:lvl5pPr marL="1371600" indent="0">
-              <a:buNone/>
-              <a:defRPr sz="1200" b="1"/>
-            </a:lvl5pPr>
-            <a:lvl6pPr marL="1714500" indent="0">
-              <a:buNone/>
-              <a:defRPr sz="1200" b="1"/>
-            </a:lvl6pPr>
-            <a:lvl7pPr marL="2057400" indent="0">
-              <a:buNone/>
-              <a:defRPr sz="1200" b="1"/>
-            </a:lvl7pPr>
-            <a:lvl8pPr marL="2400300" indent="0">
-              <a:buNone/>
-              <a:defRPr sz="1200" b="1"/>
-            </a:lvl8pPr>
-            <a:lvl9pPr marL="2743200" indent="0">
-              <a:buNone/>
-              <a:defRPr sz="1200" b="1"/>
-            </a:lvl9pPr>
+            <a:lvl1pPr>
+              <a:defRPr sz="950">
+                <a:solidFill>
+                  <a:srgbClr val="1A1A1A"/>
+                </a:solidFill>
+                <a:latin typeface="Malgun Gothic"/>
+                <a:ea typeface="Malgun Gothic"/>
+                <a:cs typeface="Malgun Gothic"/>
+              </a:defRPr>
+            </a:lvl1pPr>
           </a:lstStyle>
           <a:p>
             <a:pPr lvl="0"/>
             <a:r>
-              <a:rPr lang="en-US"/>
+              <a:rPr lang="en-US" smtClean="0"/>
               <a:t>Click to edit Master text styles</a:t>
             </a:r>
           </a:p>
@@ -1688,75 +1717,59 @@
         </p:nvSpPr>
         <p:spPr>
           <a:xfrm>
-            <a:off x="4645026" y="1631156"/>
-            <a:ext cx="4041775" cy="2963466"/>
+            <a:off x="4645025" y="2174875"/>
+            <a:ext cx="4041775" cy="3951288"/>
           </a:xfrm>
         </p:spPr>
         <p:txBody>
           <a:bodyPr/>
           <a:lstStyle>
             <a:lvl1pPr>
-              <a:defRPr sz="1800"/>
-            </a:lvl1pPr>
-            <a:lvl2pPr>
-              <a:defRPr sz="1500"/>
-            </a:lvl2pPr>
-            <a:lvl3pPr>
-              <a:defRPr sz="1350"/>
-            </a:lvl3pPr>
-            <a:lvl4pPr>
-              <a:defRPr sz="1200"/>
-            </a:lvl4pPr>
-            <a:lvl5pPr>
-              <a:defRPr sz="1200"/>
-            </a:lvl5pPr>
-            <a:lvl6pPr>
-              <a:defRPr sz="1200"/>
-            </a:lvl6pPr>
-            <a:lvl7pPr>
-              <a:defRPr sz="1200"/>
-            </a:lvl7pPr>
-            <a:lvl8pPr>
-              <a:defRPr sz="1200"/>
-            </a:lvl8pPr>
-            <a:lvl9pPr>
-              <a:defRPr sz="1200"/>
-            </a:lvl9pPr>
+              <a:defRPr sz="950">
+                <a:solidFill>
+                  <a:srgbClr val="1A1A1A"/>
+                </a:solidFill>
+                <a:latin typeface="Malgun Gothic"/>
+                <a:ea typeface="Malgun Gothic"/>
+                <a:cs typeface="Malgun Gothic"/>
+              </a:defRPr>
+            </a:lvl1pPr>
           </a:lstStyle>
           <a:p>
             <a:pPr lvl="0"/>
             <a:r>
-              <a:rPr lang="en-US"/>
+              <a:rPr lang="en-US" smtClean="0"/>
               <a:t>Click to edit Master text styles</a:t>
             </a:r>
           </a:p>
           <a:p>
             <a:pPr lvl="1"/>
             <a:r>
-              <a:rPr lang="en-US"/>
+              <a:rPr lang="en-US" smtClean="0"/>
               <a:t>Second level</a:t>
             </a:r>
           </a:p>
           <a:p>
             <a:pPr lvl="2"/>
             <a:r>
-              <a:rPr lang="en-US"/>
+              <a:rPr lang="en-US" smtClean="0"/>
               <a:t>Third level</a:t>
             </a:r>
           </a:p>
           <a:p>
             <a:pPr lvl="3"/>
             <a:r>
-              <a:rPr lang="en-US"/>
+              <a:rPr lang="en-US" smtClean="0"/>
               <a:t>Fourth level</a:t>
             </a:r>
           </a:p>
           <a:p>
             <a:pPr lvl="4"/>
             <a:r>
-              <a:rPr lang="en-US"/>
+              <a:rPr lang="en-US" smtClean="0"/>
               <a:t>Fifth level</a:t>
             </a:r>
+            <a:endParaRPr lang="en-US"/>
           </a:p>
         </p:txBody>
       </p:sp>
@@ -1773,11 +1786,22 @@
         <p:spPr/>
         <p:txBody>
           <a:bodyPr/>
-          <a:lstStyle/>
-          <a:p>
-            <a:fld id="{241EB5C9-1307-BA42-ABA2-0BC069CD8E7F}" type="datetimeFigureOut">
-              <a:rPr lang="en-US" smtClean="0"/>
-              <a:t>1/2/22</a:t>
+          <a:lstStyle>
+            <a:lvl1pPr>
+              <a:defRPr sz="950">
+                <a:solidFill>
+                  <a:srgbClr val="1A1A1A"/>
+                </a:solidFill>
+                <a:latin typeface="Malgun Gothic"/>
+                <a:ea typeface="Malgun Gothic"/>
+                <a:cs typeface="Malgun Gothic"/>
+              </a:defRPr>
+            </a:lvl1pPr>
+          </a:lstStyle>
+          <a:p>
+            <a:fld id="{5BCAD085-E8A6-8845-BD4E-CB4CCA059FC4}" type="datetimeFigureOut">
+              <a:rPr lang="en-US" smtClean="0"/>
+              <a:t>1/27/13</a:t>
             </a:fld>
             <a:endParaRPr lang="en-US"/>
           </a:p>
@@ -1796,7 +1820,18 @@
         <p:spPr/>
         <p:txBody>
           <a:bodyPr/>
-          <a:lstStyle/>
+          <a:lstStyle>
+            <a:lvl1pPr>
+              <a:defRPr sz="950">
+                <a:solidFill>
+                  <a:srgbClr val="1A1A1A"/>
+                </a:solidFill>
+                <a:latin typeface="Malgun Gothic"/>
+                <a:ea typeface="Malgun Gothic"/>
+                <a:cs typeface="Malgun Gothic"/>
+              </a:defRPr>
+            </a:lvl1pPr>
+          </a:lstStyle>
           <a:p>
             <a:endParaRPr lang="en-US"/>
           </a:p>
@@ -1815,9 +1850,20 @@
         <p:spPr/>
         <p:txBody>
           <a:bodyPr/>
-          <a:lstStyle/>
-          <a:p>
-            <a:fld id="{C5EF2332-01BF-834F-8236-50238282D533}" type="slidenum">
+          <a:lstStyle>
+            <a:lvl1pPr>
+              <a:defRPr sz="950">
+                <a:solidFill>
+                  <a:srgbClr val="1A1A1A"/>
+                </a:solidFill>
+                <a:latin typeface="Malgun Gothic"/>
+                <a:ea typeface="Malgun Gothic"/>
+                <a:cs typeface="Malgun Gothic"/>
+              </a:defRPr>
+            </a:lvl1pPr>
+          </a:lstStyle>
+          <a:p>
+            <a:fld id="{C1FF6DA9-008F-8B48-92A6-B652298478BF}" type="slidenum">
               <a:rPr lang="en-US" smtClean="0"/>
               <a:t>‹#›</a:t>
             </a:fld>
@@ -1828,7 +1874,7 @@
     </p:spTree>
     <p:extLst>
       <p:ext uri="{BB962C8B-B14F-4D97-AF65-F5344CB8AC3E}">
-        <p14:creationId xmlns:p14="http://schemas.microsoft.com/office/powerpoint/2010/main" val="2535793967"/>
+        <p14:creationId xmlns:p14="http://schemas.microsoft.com/office/powerpoint/2010/main" val="990158736"/>
       </p:ext>
     </p:extLst>
   </p:cSld>
@@ -1868,12 +1914,24 @@
         <p:spPr/>
         <p:txBody>
           <a:bodyPr/>
-          <a:lstStyle/>
-          <a:p>
-            <a:r>
-              <a:rPr lang="en-US"/>
+          <a:lstStyle>
+            <a:lvl1pPr>
+              <a:defRPr sz="2700" b="1">
+                <a:solidFill>
+                  <a:srgbClr val="977A0E"/>
+                </a:solidFill>
+                <a:latin typeface="Malgun Gothic"/>
+                <a:ea typeface="Malgun Gothic"/>
+                <a:cs typeface="Malgun Gothic"/>
+              </a:defRPr>
+            </a:lvl1pPr>
+          </a:lstStyle>
+          <a:p>
+            <a:r>
+              <a:rPr lang="en-US" smtClean="0"/>
               <a:t>Click to edit Master title style</a:t>
             </a:r>
+            <a:endParaRPr lang="en-US"/>
           </a:p>
         </p:txBody>
       </p:sp>
@@ -1890,11 +1948,22 @@
         <p:spPr/>
         <p:txBody>
           <a:bodyPr/>
-          <a:lstStyle/>
-          <a:p>
-            <a:fld id="{241EB5C9-1307-BA42-ABA2-0BC069CD8E7F}" type="datetimeFigureOut">
-              <a:rPr lang="en-US" smtClean="0"/>
-              <a:t>1/2/22</a:t>
+          <a:lstStyle>
+            <a:lvl1pPr>
+              <a:defRPr sz="950">
+                <a:solidFill>
+                  <a:srgbClr val="1A1A1A"/>
+                </a:solidFill>
+                <a:latin typeface="Malgun Gothic"/>
+                <a:ea typeface="Malgun Gothic"/>
+                <a:cs typeface="Malgun Gothic"/>
+              </a:defRPr>
+            </a:lvl1pPr>
+          </a:lstStyle>
+          <a:p>
+            <a:fld id="{5BCAD085-E8A6-8845-BD4E-CB4CCA059FC4}" type="datetimeFigureOut">
+              <a:rPr lang="en-US" smtClean="0"/>
+              <a:t>1/27/13</a:t>
             </a:fld>
             <a:endParaRPr lang="en-US"/>
           </a:p>
@@ -1913,7 +1982,18 @@
         <p:spPr/>
         <p:txBody>
           <a:bodyPr/>
-          <a:lstStyle/>
+          <a:lstStyle>
+            <a:lvl1pPr>
+              <a:defRPr sz="950">
+                <a:solidFill>
+                  <a:srgbClr val="1A1A1A"/>
+                </a:solidFill>
+                <a:latin typeface="Malgun Gothic"/>
+                <a:ea typeface="Malgun Gothic"/>
+                <a:cs typeface="Malgun Gothic"/>
+              </a:defRPr>
+            </a:lvl1pPr>
+          </a:lstStyle>
           <a:p>
             <a:endParaRPr lang="en-US"/>
           </a:p>
@@ -1932,9 +2012,20 @@
         <p:spPr/>
         <p:txBody>
           <a:bodyPr/>
-          <a:lstStyle/>
-          <a:p>
-            <a:fld id="{C5EF2332-01BF-834F-8236-50238282D533}" type="slidenum">
+          <a:lstStyle>
+            <a:lvl1pPr>
+              <a:defRPr sz="950">
+                <a:solidFill>
+                  <a:srgbClr val="1A1A1A"/>
+                </a:solidFill>
+                <a:latin typeface="Malgun Gothic"/>
+                <a:ea typeface="Malgun Gothic"/>
+                <a:cs typeface="Malgun Gothic"/>
+              </a:defRPr>
+            </a:lvl1pPr>
+          </a:lstStyle>
+          <a:p>
+            <a:fld id="{C1FF6DA9-008F-8B48-92A6-B652298478BF}" type="slidenum">
               <a:rPr lang="en-US" smtClean="0"/>
               <a:t>‹#›</a:t>
             </a:fld>
@@ -1945,7 +2036,7 @@
     </p:spTree>
     <p:extLst>
       <p:ext uri="{BB962C8B-B14F-4D97-AF65-F5344CB8AC3E}">
-        <p14:creationId xmlns:p14="http://schemas.microsoft.com/office/powerpoint/2010/main" val="3472721253"/>
+        <p14:creationId xmlns:p14="http://schemas.microsoft.com/office/powerpoint/2010/main" val="727027711"/>
       </p:ext>
     </p:extLst>
   </p:cSld>
@@ -1985,11 +2076,22 @@
         <p:spPr/>
         <p:txBody>
           <a:bodyPr/>
-          <a:lstStyle/>
-          <a:p>
-            <a:fld id="{241EB5C9-1307-BA42-ABA2-0BC069CD8E7F}" type="datetimeFigureOut">
-              <a:rPr lang="en-US" smtClean="0"/>
-              <a:t>1/2/22</a:t>
+          <a:lstStyle>
+            <a:lvl1pPr>
+              <a:defRPr sz="950">
+                <a:solidFill>
+                  <a:srgbClr val="1A1A1A"/>
+                </a:solidFill>
+                <a:latin typeface="Malgun Gothic"/>
+                <a:ea typeface="Malgun Gothic"/>
+                <a:cs typeface="Malgun Gothic"/>
+              </a:defRPr>
+            </a:lvl1pPr>
+          </a:lstStyle>
+          <a:p>
+            <a:fld id="{5BCAD085-E8A6-8845-BD4E-CB4CCA059FC4}" type="datetimeFigureOut">
+              <a:rPr lang="en-US" smtClean="0"/>
+              <a:t>1/27/13</a:t>
             </a:fld>
             <a:endParaRPr lang="en-US"/>
           </a:p>
@@ -2008,7 +2110,18 @@
         <p:spPr/>
         <p:txBody>
           <a:bodyPr/>
-          <a:lstStyle/>
+          <a:lstStyle>
+            <a:lvl1pPr>
+              <a:defRPr sz="950">
+                <a:solidFill>
+                  <a:srgbClr val="1A1A1A"/>
+                </a:solidFill>
+                <a:latin typeface="Malgun Gothic"/>
+                <a:ea typeface="Malgun Gothic"/>
+                <a:cs typeface="Malgun Gothic"/>
+              </a:defRPr>
+            </a:lvl1pPr>
+          </a:lstStyle>
           <a:p>
             <a:endParaRPr lang="en-US"/>
           </a:p>
@@ -2027,9 +2140,20 @@
         <p:spPr/>
         <p:txBody>
           <a:bodyPr/>
-          <a:lstStyle/>
-          <a:p>
-            <a:fld id="{C5EF2332-01BF-834F-8236-50238282D533}" type="slidenum">
+          <a:lstStyle>
+            <a:lvl1pPr>
+              <a:defRPr sz="950">
+                <a:solidFill>
+                  <a:srgbClr val="1A1A1A"/>
+                </a:solidFill>
+                <a:latin typeface="Malgun Gothic"/>
+                <a:ea typeface="Malgun Gothic"/>
+                <a:cs typeface="Malgun Gothic"/>
+              </a:defRPr>
+            </a:lvl1pPr>
+          </a:lstStyle>
+          <a:p>
+            <a:fld id="{C1FF6DA9-008F-8B48-92A6-B652298478BF}" type="slidenum">
               <a:rPr lang="en-US" smtClean="0"/>
               <a:t>‹#›</a:t>
             </a:fld>
@@ -2040,7 +2164,7 @@
     </p:spTree>
     <p:extLst>
       <p:ext uri="{BB962C8B-B14F-4D97-AF65-F5344CB8AC3E}">
-        <p14:creationId xmlns:p14="http://schemas.microsoft.com/office/powerpoint/2010/main" val="2130901097"/>
+        <p14:creationId xmlns:p14="http://schemas.microsoft.com/office/powerpoint/2010/main" val="1212999818"/>
       </p:ext>
     </p:extLst>
   </p:cSld>
@@ -2079,22 +2203,30 @@
         </p:nvSpPr>
         <p:spPr>
           <a:xfrm>
-            <a:off x="457201" y="204787"/>
-            <a:ext cx="3008313" cy="871538"/>
+            <a:off x="457200" y="273050"/>
+            <a:ext cx="3008313" cy="1162050"/>
           </a:xfrm>
         </p:spPr>
         <p:txBody>
           <a:bodyPr anchor="b"/>
           <a:lstStyle>
-            <a:lvl1pPr algn="l">
-              <a:defRPr sz="1500" b="1"/>
-            </a:lvl1pPr>
-          </a:lstStyle>
-          <a:p>
-            <a:r>
-              <a:rPr lang="en-US"/>
+            <a:lvl1pPr>
+              <a:defRPr sz="2700" b="1">
+                <a:solidFill>
+                  <a:srgbClr val="977A0E"/>
+                </a:solidFill>
+                <a:latin typeface="Malgun Gothic"/>
+                <a:ea typeface="Malgun Gothic"/>
+                <a:cs typeface="Malgun Gothic"/>
+              </a:defRPr>
+            </a:lvl1pPr>
+          </a:lstStyle>
+          <a:p>
+            <a:r>
+              <a:rPr lang="en-US" smtClean="0"/>
               <a:t>Click to edit Master title style</a:t>
             </a:r>
+            <a:endParaRPr lang="en-US"/>
           </a:p>
         </p:txBody>
       </p:sp>
@@ -2110,75 +2242,59 @@
         </p:nvSpPr>
         <p:spPr>
           <a:xfrm>
-            <a:off x="3575050" y="204788"/>
-            <a:ext cx="5111750" cy="4389835"/>
+            <a:off x="3575050" y="273050"/>
+            <a:ext cx="5111750" cy="5853113"/>
           </a:xfrm>
         </p:spPr>
         <p:txBody>
           <a:bodyPr/>
           <a:lstStyle>
             <a:lvl1pPr>
-              <a:defRPr sz="2400"/>
-            </a:lvl1pPr>
-            <a:lvl2pPr>
-              <a:defRPr sz="2100"/>
-            </a:lvl2pPr>
-            <a:lvl3pPr>
-              <a:defRPr sz="1800"/>
-            </a:lvl3pPr>
-            <a:lvl4pPr>
-              <a:defRPr sz="1500"/>
-            </a:lvl4pPr>
-            <a:lvl5pPr>
-              <a:defRPr sz="1500"/>
-            </a:lvl5pPr>
-            <a:lvl6pPr>
-              <a:defRPr sz="1500"/>
-            </a:lvl6pPr>
-            <a:lvl7pPr>
-              <a:defRPr sz="1500"/>
-            </a:lvl7pPr>
-            <a:lvl8pPr>
-              <a:defRPr sz="1500"/>
-            </a:lvl8pPr>
-            <a:lvl9pPr>
-              <a:defRPr sz="1500"/>
-            </a:lvl9pPr>
+              <a:defRPr sz="950">
+                <a:solidFill>
+                  <a:srgbClr val="1A1A1A"/>
+                </a:solidFill>
+                <a:latin typeface="Malgun Gothic"/>
+                <a:ea typeface="Malgun Gothic"/>
+                <a:cs typeface="Malgun Gothic"/>
+              </a:defRPr>
+            </a:lvl1pPr>
           </a:lstStyle>
           <a:p>
             <a:pPr lvl="0"/>
             <a:r>
-              <a:rPr lang="en-US"/>
+              <a:rPr lang="en-US" smtClean="0"/>
               <a:t>Click to edit Master text styles</a:t>
             </a:r>
           </a:p>
           <a:p>
             <a:pPr lvl="1"/>
             <a:r>
-              <a:rPr lang="en-US"/>
+              <a:rPr lang="en-US" smtClean="0"/>
               <a:t>Second level</a:t>
             </a:r>
           </a:p>
           <a:p>
             <a:pPr lvl="2"/>
             <a:r>
-              <a:rPr lang="en-US"/>
+              <a:rPr lang="en-US" smtClean="0"/>
               <a:t>Third level</a:t>
             </a:r>
           </a:p>
           <a:p>
             <a:pPr lvl="3"/>
             <a:r>
-              <a:rPr lang="en-US"/>
+              <a:rPr lang="en-US" smtClean="0"/>
               <a:t>Fourth level</a:t>
             </a:r>
           </a:p>
           <a:p>
             <a:pPr lvl="4"/>
             <a:r>
-              <a:rPr lang="en-US"/>
+              <a:rPr lang="en-US" smtClean="0"/>
               <a:t>Fifth level</a:t>
             </a:r>
+            <a:endParaRPr lang="en-US"/>
           </a:p>
         </p:txBody>
       </p:sp>
@@ -2194,54 +2310,28 @@
         </p:nvSpPr>
         <p:spPr>
           <a:xfrm>
-            <a:off x="457201" y="1076326"/>
-            <a:ext cx="3008313" cy="3518297"/>
+            <a:off x="457200" y="1435100"/>
+            <a:ext cx="3008313" cy="4691063"/>
           </a:xfrm>
         </p:spPr>
         <p:txBody>
           <a:bodyPr/>
           <a:lstStyle>
-            <a:lvl1pPr marL="0" indent="0">
-              <a:buNone/>
-              <a:defRPr sz="1050"/>
-            </a:lvl1pPr>
-            <a:lvl2pPr marL="342900" indent="0">
-              <a:buNone/>
-              <a:defRPr sz="900"/>
-            </a:lvl2pPr>
-            <a:lvl3pPr marL="685800" indent="0">
-              <a:buNone/>
-              <a:defRPr sz="750"/>
-            </a:lvl3pPr>
-            <a:lvl4pPr marL="1028700" indent="0">
-              <a:buNone/>
-              <a:defRPr sz="675"/>
-            </a:lvl4pPr>
-            <a:lvl5pPr marL="1371600" indent="0">
-              <a:buNone/>
-              <a:defRPr sz="675"/>
-            </a:lvl5pPr>
-            <a:lvl6pPr marL="1714500" indent="0">
-              <a:buNone/>
-              <a:defRPr sz="675"/>
-            </a:lvl6pPr>
-            <a:lvl7pPr marL="2057400" indent="0">
-              <a:buNone/>
-              <a:defRPr sz="675"/>
-            </a:lvl7pPr>
-            <a:lvl8pPr marL="2400300" indent="0">
-              <a:buNone/>
-              <a:defRPr sz="675"/>
-            </a:lvl8pPr>
-            <a:lvl9pPr marL="2743200" indent="0">
-              <a:buNone/>
-              <a:defRPr sz="675"/>
-            </a:lvl9pPr>
+            <a:lvl1pPr>
+              <a:defRPr sz="950">
+                <a:solidFill>
+                  <a:srgbClr val="1A1A1A"/>
+                </a:solidFill>
+                <a:latin typeface="Malgun Gothic"/>
+                <a:ea typeface="Malgun Gothic"/>
+                <a:cs typeface="Malgun Gothic"/>
+              </a:defRPr>
+            </a:lvl1pPr>
           </a:lstStyle>
           <a:p>
             <a:pPr lvl="0"/>
             <a:r>
-              <a:rPr lang="en-US"/>
+              <a:rPr lang="en-US" smtClean="0"/>
               <a:t>Click to edit Master text styles</a:t>
             </a:r>
           </a:p>
@@ -2260,11 +2350,22 @@
         <p:spPr/>
         <p:txBody>
           <a:bodyPr/>
-          <a:lstStyle/>
-          <a:p>
-            <a:fld id="{241EB5C9-1307-BA42-ABA2-0BC069CD8E7F}" type="datetimeFigureOut">
-              <a:rPr lang="en-US" smtClean="0"/>
-              <a:t>1/2/22</a:t>
+          <a:lstStyle>
+            <a:lvl1pPr>
+              <a:defRPr sz="950">
+                <a:solidFill>
+                  <a:srgbClr val="1A1A1A"/>
+                </a:solidFill>
+                <a:latin typeface="Malgun Gothic"/>
+                <a:ea typeface="Malgun Gothic"/>
+                <a:cs typeface="Malgun Gothic"/>
+              </a:defRPr>
+            </a:lvl1pPr>
+          </a:lstStyle>
+          <a:p>
+            <a:fld id="{5BCAD085-E8A6-8845-BD4E-CB4CCA059FC4}" type="datetimeFigureOut">
+              <a:rPr lang="en-US" smtClean="0"/>
+              <a:t>1/27/13</a:t>
             </a:fld>
             <a:endParaRPr lang="en-US"/>
           </a:p>
@@ -2283,7 +2384,18 @@
         <p:spPr/>
         <p:txBody>
           <a:bodyPr/>
-          <a:lstStyle/>
+          <a:lstStyle>
+            <a:lvl1pPr>
+              <a:defRPr sz="950">
+                <a:solidFill>
+                  <a:srgbClr val="1A1A1A"/>
+                </a:solidFill>
+                <a:latin typeface="Malgun Gothic"/>
+                <a:ea typeface="Malgun Gothic"/>
+                <a:cs typeface="Malgun Gothic"/>
+              </a:defRPr>
+            </a:lvl1pPr>
+          </a:lstStyle>
           <a:p>
             <a:endParaRPr lang="en-US"/>
           </a:p>
@@ -2302,9 +2414,20 @@
         <p:spPr/>
         <p:txBody>
           <a:bodyPr/>
-          <a:lstStyle/>
-          <a:p>
-            <a:fld id="{C5EF2332-01BF-834F-8236-50238282D533}" type="slidenum">
+          <a:lstStyle>
+            <a:lvl1pPr>
+              <a:defRPr sz="950">
+                <a:solidFill>
+                  <a:srgbClr val="1A1A1A"/>
+                </a:solidFill>
+                <a:latin typeface="Malgun Gothic"/>
+                <a:ea typeface="Malgun Gothic"/>
+                <a:cs typeface="Malgun Gothic"/>
+              </a:defRPr>
+            </a:lvl1pPr>
+          </a:lstStyle>
+          <a:p>
+            <a:fld id="{C1FF6DA9-008F-8B48-92A6-B652298478BF}" type="slidenum">
               <a:rPr lang="en-US" smtClean="0"/>
               <a:t>‹#›</a:t>
             </a:fld>
@@ -2315,7 +2438,7 @@
     </p:spTree>
     <p:extLst>
       <p:ext uri="{BB962C8B-B14F-4D97-AF65-F5344CB8AC3E}">
-        <p14:creationId xmlns:p14="http://schemas.microsoft.com/office/powerpoint/2010/main" val="3540895647"/>
+        <p14:creationId xmlns:p14="http://schemas.microsoft.com/office/powerpoint/2010/main" val="1840726560"/>
       </p:ext>
     </p:extLst>
   </p:cSld>
@@ -2354,22 +2477,30 @@
         </p:nvSpPr>
         <p:spPr>
           <a:xfrm>
-            <a:off x="1792288" y="3600450"/>
-            <a:ext cx="5486400" cy="425054"/>
+            <a:off x="1792288" y="4800600"/>
+            <a:ext cx="5486400" cy="566738"/>
           </a:xfrm>
         </p:spPr>
         <p:txBody>
           <a:bodyPr anchor="b"/>
           <a:lstStyle>
-            <a:lvl1pPr algn="l">
-              <a:defRPr sz="1500" b="1"/>
-            </a:lvl1pPr>
-          </a:lstStyle>
-          <a:p>
-            <a:r>
-              <a:rPr lang="en-US"/>
+            <a:lvl1pPr>
+              <a:defRPr sz="2700" b="1">
+                <a:solidFill>
+                  <a:srgbClr val="977A0E"/>
+                </a:solidFill>
+                <a:latin typeface="Malgun Gothic"/>
+                <a:ea typeface="Malgun Gothic"/>
+                <a:cs typeface="Malgun Gothic"/>
+              </a:defRPr>
+            </a:lvl1pPr>
+          </a:lstStyle>
+          <a:p>
+            <a:r>
+              <a:rPr lang="en-US" smtClean="0"/>
               <a:t>Click to edit Master title style</a:t>
             </a:r>
+            <a:endParaRPr lang="en-US"/>
           </a:p>
         </p:txBody>
       </p:sp>
@@ -2385,49 +2516,23 @@
         </p:nvSpPr>
         <p:spPr>
           <a:xfrm>
-            <a:off x="1792288" y="459581"/>
-            <a:ext cx="5486400" cy="3086100"/>
+            <a:off x="1792288" y="612775"/>
+            <a:ext cx="5486400" cy="4114800"/>
           </a:xfrm>
         </p:spPr>
         <p:txBody>
           <a:bodyPr/>
           <a:lstStyle>
-            <a:lvl1pPr marL="0" indent="0">
-              <a:buNone/>
-              <a:defRPr sz="2400"/>
-            </a:lvl1pPr>
-            <a:lvl2pPr marL="342900" indent="0">
-              <a:buNone/>
-              <a:defRPr sz="2100"/>
-            </a:lvl2pPr>
-            <a:lvl3pPr marL="685800" indent="0">
-              <a:buNone/>
-              <a:defRPr sz="1800"/>
-            </a:lvl3pPr>
-            <a:lvl4pPr marL="1028700" indent="0">
-              <a:buNone/>
-              <a:defRPr sz="1500"/>
-            </a:lvl4pPr>
-            <a:lvl5pPr marL="1371600" indent="0">
-              <a:buNone/>
-              <a:defRPr sz="1500"/>
-            </a:lvl5pPr>
-            <a:lvl6pPr marL="1714500" indent="0">
-              <a:buNone/>
-              <a:defRPr sz="1500"/>
-            </a:lvl6pPr>
-            <a:lvl7pPr marL="2057400" indent="0">
-              <a:buNone/>
-              <a:defRPr sz="1500"/>
-            </a:lvl7pPr>
-            <a:lvl8pPr marL="2400300" indent="0">
-              <a:buNone/>
-              <a:defRPr sz="1500"/>
-            </a:lvl8pPr>
-            <a:lvl9pPr marL="2743200" indent="0">
-              <a:buNone/>
-              <a:defRPr sz="1500"/>
-            </a:lvl9pPr>
+            <a:lvl1pPr>
+              <a:defRPr sz="950">
+                <a:solidFill>
+                  <a:srgbClr val="1A1A1A"/>
+                </a:solidFill>
+                <a:latin typeface="Malgun Gothic"/>
+                <a:ea typeface="Malgun Gothic"/>
+                <a:cs typeface="Malgun Gothic"/>
+              </a:defRPr>
+            </a:lvl1pPr>
           </a:lstStyle>
           <a:p>
             <a:endParaRPr lang="en-US"/>
@@ -2446,54 +2551,28 @@
         </p:nvSpPr>
         <p:spPr>
           <a:xfrm>
-            <a:off x="1792288" y="4025503"/>
-            <a:ext cx="5486400" cy="603647"/>
+            <a:off x="1792288" y="5367338"/>
+            <a:ext cx="5486400" cy="804862"/>
           </a:xfrm>
         </p:spPr>
         <p:txBody>
           <a:bodyPr/>
           <a:lstStyle>
-            <a:lvl1pPr marL="0" indent="0">
-              <a:buNone/>
-              <a:defRPr sz="1050"/>
-            </a:lvl1pPr>
-            <a:lvl2pPr marL="342900" indent="0">
-              <a:buNone/>
-              <a:defRPr sz="900"/>
-            </a:lvl2pPr>
-            <a:lvl3pPr marL="685800" indent="0">
-              <a:buNone/>
-              <a:defRPr sz="750"/>
-            </a:lvl3pPr>
-            <a:lvl4pPr marL="1028700" indent="0">
-              <a:buNone/>
-              <a:defRPr sz="675"/>
-            </a:lvl4pPr>
-            <a:lvl5pPr marL="1371600" indent="0">
-              <a:buNone/>
-              <a:defRPr sz="675"/>
-            </a:lvl5pPr>
-            <a:lvl6pPr marL="1714500" indent="0">
-              <a:buNone/>
-              <a:defRPr sz="675"/>
-            </a:lvl6pPr>
-            <a:lvl7pPr marL="2057400" indent="0">
-              <a:buNone/>
-              <a:defRPr sz="675"/>
-            </a:lvl7pPr>
-            <a:lvl8pPr marL="2400300" indent="0">
-              <a:buNone/>
-              <a:defRPr sz="675"/>
-            </a:lvl8pPr>
-            <a:lvl9pPr marL="2743200" indent="0">
-              <a:buNone/>
-              <a:defRPr sz="675"/>
-            </a:lvl9pPr>
+            <a:lvl1pPr>
+              <a:defRPr sz="950">
+                <a:solidFill>
+                  <a:srgbClr val="1A1A1A"/>
+                </a:solidFill>
+                <a:latin typeface="Malgun Gothic"/>
+                <a:ea typeface="Malgun Gothic"/>
+                <a:cs typeface="Malgun Gothic"/>
+              </a:defRPr>
+            </a:lvl1pPr>
           </a:lstStyle>
           <a:p>
             <a:pPr lvl="0"/>
             <a:r>
-              <a:rPr lang="en-US"/>
+              <a:rPr lang="en-US" smtClean="0"/>
               <a:t>Click to edit Master text styles</a:t>
             </a:r>
           </a:p>
@@ -2512,11 +2591,22 @@
         <p:spPr/>
         <p:txBody>
           <a:bodyPr/>
-          <a:lstStyle/>
-          <a:p>
-            <a:fld id="{241EB5C9-1307-BA42-ABA2-0BC069CD8E7F}" type="datetimeFigureOut">
-              <a:rPr lang="en-US" smtClean="0"/>
-              <a:t>1/2/22</a:t>
+          <a:lstStyle>
+            <a:lvl1pPr>
+              <a:defRPr sz="950">
+                <a:solidFill>
+                  <a:srgbClr val="1A1A1A"/>
+                </a:solidFill>
+                <a:latin typeface="Malgun Gothic"/>
+                <a:ea typeface="Malgun Gothic"/>
+                <a:cs typeface="Malgun Gothic"/>
+              </a:defRPr>
+            </a:lvl1pPr>
+          </a:lstStyle>
+          <a:p>
+            <a:fld id="{5BCAD085-E8A6-8845-BD4E-CB4CCA059FC4}" type="datetimeFigureOut">
+              <a:rPr lang="en-US" smtClean="0"/>
+              <a:t>1/27/13</a:t>
             </a:fld>
             <a:endParaRPr lang="en-US"/>
           </a:p>
@@ -2535,7 +2625,18 @@
         <p:spPr/>
         <p:txBody>
           <a:bodyPr/>
-          <a:lstStyle/>
+          <a:lstStyle>
+            <a:lvl1pPr>
+              <a:defRPr sz="950">
+                <a:solidFill>
+                  <a:srgbClr val="1A1A1A"/>
+                </a:solidFill>
+                <a:latin typeface="Malgun Gothic"/>
+                <a:ea typeface="Malgun Gothic"/>
+                <a:cs typeface="Malgun Gothic"/>
+              </a:defRPr>
+            </a:lvl1pPr>
+          </a:lstStyle>
           <a:p>
             <a:endParaRPr lang="en-US"/>
           </a:p>
@@ -2554,9 +2655,20 @@
         <p:spPr/>
         <p:txBody>
           <a:bodyPr/>
-          <a:lstStyle/>
-          <a:p>
-            <a:fld id="{C5EF2332-01BF-834F-8236-50238282D533}" type="slidenum">
+          <a:lstStyle>
+            <a:lvl1pPr>
+              <a:defRPr sz="950">
+                <a:solidFill>
+                  <a:srgbClr val="1A1A1A"/>
+                </a:solidFill>
+                <a:latin typeface="Malgun Gothic"/>
+                <a:ea typeface="Malgun Gothic"/>
+                <a:cs typeface="Malgun Gothic"/>
+              </a:defRPr>
+            </a:lvl1pPr>
+          </a:lstStyle>
+          <a:p>
+            <a:fld id="{C1FF6DA9-008F-8B48-92A6-B652298478BF}" type="slidenum">
               <a:rPr lang="en-US" smtClean="0"/>
               <a:t>‹#›</a:t>
             </a:fld>
@@ -2567,7 +2679,7 @@
     </p:spTree>
     <p:extLst>
       <p:ext uri="{BB962C8B-B14F-4D97-AF65-F5344CB8AC3E}">
-        <p14:creationId xmlns:p14="http://schemas.microsoft.com/office/powerpoint/2010/main" val="3566899855"/>
+        <p14:creationId xmlns:p14="http://schemas.microsoft.com/office/powerpoint/2010/main" val="3889236939"/>
       </p:ext>
     </p:extLst>
   </p:cSld>
@@ -2611,8 +2723,8 @@
         </p:nvSpPr>
         <p:spPr>
           <a:xfrm>
-            <a:off x="457200" y="205979"/>
-            <a:ext cx="8229600" cy="857250"/>
+            <a:off x="457200" y="274638"/>
+            <a:ext cx="8229600" cy="1143000"/>
           </a:xfrm>
           <a:prstGeom prst="rect">
             <a:avLst/>
@@ -2622,12 +2734,24 @@
           <a:bodyPr anchor="ctr" bIns="45720" lIns="91440" rIns="91440" rtlCol="0" tIns="45720" vert="horz">
             <a:normAutofit/>
           </a:bodyPr>
-          <a:lstStyle/>
-          <a:p>
-            <a:r>
-              <a:rPr lang="en-US"/>
+          <a:lstStyle>
+            <a:lvl1pPr>
+              <a:defRPr b="1" sz="2700">
+                <a:solidFill>
+                  <a:srgbClr val="977A0E"/>
+                </a:solidFill>
+                <a:latin typeface="Malgun Gothic"/>
+                <a:ea typeface="Malgun Gothic"/>
+                <a:cs typeface="Malgun Gothic"/>
+              </a:defRPr>
+            </a:lvl1pPr>
+          </a:lstStyle>
+          <a:p>
+            <a:r>
+              <a:rPr lang="en-US" smtClean="0"/>
               <a:t>Click to edit Master title style</a:t>
             </a:r>
+            <a:endParaRPr lang="en-US"/>
           </a:p>
         </p:txBody>
       </p:sp>
@@ -2643,8 +2767,8 @@
         </p:nvSpPr>
         <p:spPr>
           <a:xfrm>
-            <a:off x="457200" y="1200151"/>
-            <a:ext cx="8229600" cy="3394472"/>
+            <a:off x="457200" y="1600200"/>
+            <a:ext cx="8229600" cy="4525963"/>
           </a:xfrm>
           <a:prstGeom prst="rect">
             <a:avLst/>
@@ -2654,41 +2778,53 @@
           <a:bodyPr bIns="45720" lIns="91440" rIns="91440" rtlCol="0" tIns="45720" vert="horz">
             <a:normAutofit/>
           </a:bodyPr>
-          <a:lstStyle/>
+          <a:lstStyle>
+            <a:lvl1pPr>
+              <a:defRPr sz="950">
+                <a:solidFill>
+                  <a:srgbClr val="1A1A1A"/>
+                </a:solidFill>
+                <a:latin typeface="Malgun Gothic"/>
+                <a:ea typeface="Malgun Gothic"/>
+                <a:cs typeface="Malgun Gothic"/>
+              </a:defRPr>
+            </a:lvl1pPr>
+          </a:lstStyle>
           <a:p>
             <a:pPr lvl="0"/>
             <a:r>
-              <a:rPr lang="en-US"/>
+              <a:rPr lang="en-US" smtClean="0"/>
               <a:t>Click to edit Master text styles</a:t>
             </a:r>
           </a:p>
           <a:p>
             <a:pPr lvl="1"/>
             <a:r>
-              <a:rPr lang="en-US"/>
+              <a:rPr lang="en-US" smtClean="0"/>
               <a:t>Second level</a:t>
             </a:r>
           </a:p>
           <a:p>
             <a:pPr lvl="2"/>
             <a:r>
-              <a:rPr lang="en-US"/>
+              <a:rPr lang="en-US" smtClean="0"/>
               <a:t>Third level</a:t>
             </a:r>
           </a:p>
           <a:p>
             <a:pPr lvl="3"/>
             <a:r>
-              <a:rPr lang="en-US"/>
+              <a:rPr lang="en-US" smtClean="0"/>
               <a:t>Fourth level</a:t>
             </a:r>
           </a:p>
           <a:p>
             <a:pPr lvl="4"/>
             <a:r>
-              <a:rPr lang="en-US"/>
+              <a:rPr lang="en-US" smtClean="0"/>
               <a:t>Fifth level</a:t>
             </a:r>
+            <a:endParaRPr lang="en-US"/>
           </a:p>
         </p:txBody>
       </p:sp>
@@ -2704,8 +2840,8 @@
         </p:nvSpPr>
         <p:spPr>
           <a:xfrm>
-            <a:off x="457200" y="4767263"/>
-            <a:ext cx="2133600" cy="273844"/>
+            <a:off x="457200" y="6356350"/>
+            <a:ext cx="2133600" cy="365125"/>
           </a:xfrm>
           <a:prstGeom prst="rect">
             <a:avLst/>
@@ -2714,20 +2850,21 @@
         <p:txBody>
           <a:bodyPr anchor="ctr" bIns="45720" lIns="91440" rIns="91440" rtlCol="0" tIns="45720" vert="horz"/>
           <a:lstStyle>
-            <a:lvl1pPr algn="l">
-              <a:defRPr sz="900">
-                <a:solidFill>
-                  <a:schemeClr val="tx1">
-                    <a:tint val="75000"/>
-                  </a:schemeClr>
-                </a:solidFill>
-              </a:defRPr>
-            </a:lvl1pPr>
-          </a:lstStyle>
-          <a:p>
-            <a:fld id="{241EB5C9-1307-BA42-ABA2-0BC069CD8E7F}" type="datetimeFigureOut">
-              <a:rPr lang="en-US" smtClean="0"/>
-              <a:t>1/2/22</a:t>
+            <a:lvl1pPr>
+              <a:defRPr sz="950">
+                <a:solidFill>
+                  <a:srgbClr val="1A1A1A"/>
+                </a:solidFill>
+                <a:latin typeface="Malgun Gothic"/>
+                <a:ea typeface="Malgun Gothic"/>
+                <a:cs typeface="Malgun Gothic"/>
+              </a:defRPr>
+            </a:lvl1pPr>
+          </a:lstStyle>
+          <a:p>
+            <a:fld id="{5BCAD085-E8A6-8845-BD4E-CB4CCA059FC4}" type="datetimeFigureOut">
+              <a:rPr lang="en-US" smtClean="0"/>
+              <a:t>1/27/13</a:t>
             </a:fld>
             <a:endParaRPr lang="en-US"/>
           </a:p>
@@ -2745,8 +2882,8 @@
         </p:nvSpPr>
         <p:spPr>
           <a:xfrm>
-            <a:off x="3124200" y="4767263"/>
-            <a:ext cx="2895600" cy="273844"/>
+            <a:off x="3124200" y="6356350"/>
+            <a:ext cx="2895600" cy="365125"/>
           </a:xfrm>
           <a:prstGeom prst="rect">
             <a:avLst/>
@@ -2755,13 +2892,14 @@
         <p:txBody>
           <a:bodyPr anchor="ctr" bIns="45720" lIns="91440" rIns="91440" rtlCol="0" tIns="45720" vert="horz"/>
           <a:lstStyle>
-            <a:lvl1pPr algn="ctr">
-              <a:defRPr sz="900">
-                <a:solidFill>
-                  <a:schemeClr val="tx1">
-                    <a:tint val="75000"/>
-                  </a:schemeClr>
-                </a:solidFill>
+            <a:lvl1pPr>
+              <a:defRPr sz="950">
+                <a:solidFill>
+                  <a:srgbClr val="1A1A1A"/>
+                </a:solidFill>
+                <a:latin typeface="Malgun Gothic"/>
+                <a:ea typeface="Malgun Gothic"/>
+                <a:cs typeface="Malgun Gothic"/>
               </a:defRPr>
             </a:lvl1pPr>
           </a:lstStyle>
@@ -2782,8 +2920,8 @@
         </p:nvSpPr>
         <p:spPr>
           <a:xfrm>
-            <a:off x="6553200" y="4767263"/>
-            <a:ext cx="2133600" cy="273844"/>
+            <a:off x="6553200" y="6356350"/>
+            <a:ext cx="2133600" cy="365125"/>
           </a:xfrm>
           <a:prstGeom prst="rect">
             <a:avLst/>
@@ -2792,18 +2930,19 @@
         <p:txBody>
           <a:bodyPr anchor="ctr" bIns="45720" lIns="91440" rIns="91440" rtlCol="0" tIns="45720" vert="horz"/>
           <a:lstStyle>
-            <a:lvl1pPr algn="r">
-              <a:defRPr sz="900">
-                <a:solidFill>
-                  <a:schemeClr val="tx1">
-                    <a:tint val="75000"/>
-                  </a:schemeClr>
-                </a:solidFill>
-              </a:defRPr>
-            </a:lvl1pPr>
-          </a:lstStyle>
-          <a:p>
-            <a:fld id="{C5EF2332-01BF-834F-8236-50238282D533}" type="slidenum">
+            <a:lvl1pPr>
+              <a:defRPr sz="950">
+                <a:solidFill>
+                  <a:srgbClr val="1A1A1A"/>
+                </a:solidFill>
+                <a:latin typeface="Malgun Gothic"/>
+                <a:ea typeface="Malgun Gothic"/>
+                <a:cs typeface="Malgun Gothic"/>
+              </a:defRPr>
+            </a:lvl1pPr>
+          </a:lstStyle>
+          <a:p>
+            <a:fld id="{C1FF6DA9-008F-8B48-92A6-B652298478BF}" type="slidenum">
               <a:rPr lang="en-US" smtClean="0"/>
               <a:t>‹#›</a:t>
             </a:fld>
@@ -2814,7 +2953,7 @@
     </p:spTree>
     <p:extLst>
       <p:ext uri="{BB962C8B-B14F-4D97-AF65-F5344CB8AC3E}">
-        <p14:creationId xmlns:p14="http://schemas.microsoft.com/office/powerpoint/2010/main" val="3676200875"/>
+        <p14:creationId xmlns:p14="http://schemas.microsoft.com/office/powerpoint/2010/main" val="2209977519"/>
       </p:ext>
     </p:extLst>
   </p:cSld>
@@ -2834,12 +2973,12 @@
   </p:sldLayoutIdLst>
   <p:txStyles>
     <p:titleStyle>
-      <a:lvl1pPr algn="ctr" defTabSz="342900" eaLnBrk="1" hangingPunct="1" latinLnBrk="0" rtl="0">
+      <a:lvl1pPr algn="ctr" defTabSz="457200" eaLnBrk="1" hangingPunct="1" latinLnBrk="0" rtl="0">
         <a:spcBef>
           <a:spcPct val="0"/>
         </a:spcBef>
         <a:buNone/>
-        <a:defRPr kern="1200" sz="3300">
+        <a:defRPr kern="1200" sz="4400">
           <a:solidFill>
             <a:schemeClr val="tx1"/>
           </a:solidFill>
@@ -2850,7 +2989,37 @@
       </a:lvl1pPr>
     </p:titleStyle>
     <p:bodyStyle>
-      <a:lvl1pPr algn="l" defTabSz="342900" eaLnBrk="1" hangingPunct="1" indent="-342900" latinLnBrk="0" marL="342900" rtl="0">
+      <a:lvl1pPr algn="l" defTabSz="457200" eaLnBrk="1" hangingPunct="1" indent="-342900" latinLnBrk="0" marL="342900" rtl="0">
+        <a:spcBef>
+          <a:spcPct val="20000"/>
+        </a:spcBef>
+        <a:buFont typeface="Arial"/>
+        <a:buChar char="•"/>
+        <a:defRPr kern="1200" sz="3200">
+          <a:solidFill>
+            <a:schemeClr val="tx1"/>
+          </a:solidFill>
+          <a:latin typeface="+mn-lt"/>
+          <a:ea typeface="+mn-ea"/>
+          <a:cs typeface="+mn-cs"/>
+        </a:defRPr>
+      </a:lvl1pPr>
+      <a:lvl2pPr algn="l" defTabSz="457200" eaLnBrk="1" hangingPunct="1" indent="-285750" latinLnBrk="0" marL="742950" rtl="0">
+        <a:spcBef>
+          <a:spcPct val="20000"/>
+        </a:spcBef>
+        <a:buFont typeface="Arial"/>
+        <a:buChar char="–"/>
+        <a:defRPr kern="1200" sz="2800">
+          <a:solidFill>
+            <a:schemeClr val="tx1"/>
+          </a:solidFill>
+          <a:latin typeface="+mn-lt"/>
+          <a:ea typeface="+mn-ea"/>
+          <a:cs typeface="+mn-cs"/>
+        </a:defRPr>
+      </a:lvl2pPr>
+      <a:lvl3pPr algn="l" defTabSz="457200" eaLnBrk="1" hangingPunct="1" indent="-228600" latinLnBrk="0" marL="1143000" rtl="0">
         <a:spcBef>
           <a:spcPct val="20000"/>
         </a:spcBef>
@@ -2864,44 +3033,14 @@
           <a:ea typeface="+mn-ea"/>
           <a:cs typeface="+mn-cs"/>
         </a:defRPr>
-      </a:lvl1pPr>
-      <a:lvl2pPr algn="l" defTabSz="342900" eaLnBrk="1" hangingPunct="1" indent="-342900" latinLnBrk="0" marL="685800" rtl="0">
+      </a:lvl3pPr>
+      <a:lvl4pPr algn="l" defTabSz="457200" eaLnBrk="1" hangingPunct="1" indent="-228600" latinLnBrk="0" marL="1600200" rtl="0">
         <a:spcBef>
           <a:spcPct val="20000"/>
         </a:spcBef>
         <a:buFont typeface="Arial"/>
         <a:buChar char="–"/>
-        <a:defRPr kern="1200" sz="2100">
-          <a:solidFill>
-            <a:schemeClr val="tx1"/>
-          </a:solidFill>
-          <a:latin typeface="+mn-lt"/>
-          <a:ea typeface="+mn-ea"/>
-          <a:cs typeface="+mn-cs"/>
-        </a:defRPr>
-      </a:lvl2pPr>
-      <a:lvl3pPr algn="l" defTabSz="342900" eaLnBrk="1" hangingPunct="1" indent="-342900" latinLnBrk="0" marL="1028700" rtl="0">
-        <a:spcBef>
-          <a:spcPct val="20000"/>
-        </a:spcBef>
-        <a:buFont typeface="Arial"/>
-        <a:buChar char="•"/>
-        <a:defRPr kern="1200" sz="1800">
-          <a:solidFill>
-            <a:schemeClr val="tx1"/>
-          </a:solidFill>
-          <a:latin typeface="+mn-lt"/>
-          <a:ea typeface="+mn-ea"/>
-          <a:cs typeface="+mn-cs"/>
-        </a:defRPr>
-      </a:lvl3pPr>
-      <a:lvl4pPr algn="l" defTabSz="342900" eaLnBrk="1" hangingPunct="1" indent="-342900" latinLnBrk="0" marL="1371600" rtl="0">
-        <a:spcBef>
-          <a:spcPct val="20000"/>
-        </a:spcBef>
-        <a:buFont typeface="Arial"/>
-        <a:buChar char="–"/>
-        <a:defRPr kern="1200" sz="1500">
+        <a:defRPr kern="1200" sz="2000">
           <a:solidFill>
             <a:schemeClr val="tx1"/>
           </a:solidFill>
@@ -2910,13 +3049,13 @@
           <a:cs typeface="+mn-cs"/>
         </a:defRPr>
       </a:lvl4pPr>
-      <a:lvl5pPr algn="l" defTabSz="342900" eaLnBrk="1" hangingPunct="1" indent="-342900" latinLnBrk="0" marL="1714500" rtl="0">
+      <a:lvl5pPr algn="l" defTabSz="457200" eaLnBrk="1" hangingPunct="1" indent="-228600" latinLnBrk="0" marL="2057400" rtl="0">
         <a:spcBef>
           <a:spcPct val="20000"/>
         </a:spcBef>
         <a:buFont typeface="Arial"/>
         <a:buChar char="»"/>
-        <a:defRPr kern="1200" sz="1500">
+        <a:defRPr kern="1200" sz="2000">
           <a:solidFill>
             <a:schemeClr val="tx1"/>
           </a:solidFill>
@@ -2925,13 +3064,13 @@
           <a:cs typeface="+mn-cs"/>
         </a:defRPr>
       </a:lvl5pPr>
-      <a:lvl6pPr algn="l" defTabSz="342900" eaLnBrk="1" hangingPunct="1" indent="-342900" latinLnBrk="0" marL="2057400" rtl="0">
+      <a:lvl6pPr algn="l" defTabSz="457200" eaLnBrk="1" hangingPunct="1" indent="-228600" latinLnBrk="0" marL="2514600" rtl="0">
         <a:spcBef>
           <a:spcPct val="20000"/>
         </a:spcBef>
         <a:buFont typeface="Arial"/>
         <a:buChar char="•"/>
-        <a:defRPr kern="1200" sz="1500">
+        <a:defRPr kern="1200" sz="2000">
           <a:solidFill>
             <a:schemeClr val="tx1"/>
           </a:solidFill>
@@ -2940,13 +3079,13 @@
           <a:cs typeface="+mn-cs"/>
         </a:defRPr>
       </a:lvl6pPr>
-      <a:lvl7pPr algn="l" defTabSz="342900" eaLnBrk="1" hangingPunct="1" indent="-342900" latinLnBrk="0" marL="2400300" rtl="0">
+      <a:lvl7pPr algn="l" defTabSz="457200" eaLnBrk="1" hangingPunct="1" indent="-228600" latinLnBrk="0" marL="2971800" rtl="0">
         <a:spcBef>
           <a:spcPct val="20000"/>
         </a:spcBef>
         <a:buFont typeface="Arial"/>
         <a:buChar char="•"/>
-        <a:defRPr kern="1200" sz="1500">
+        <a:defRPr kern="1200" sz="2000">
           <a:solidFill>
             <a:schemeClr val="tx1"/>
           </a:solidFill>
@@ -2955,13 +3094,13 @@
           <a:cs typeface="+mn-cs"/>
         </a:defRPr>
       </a:lvl7pPr>
-      <a:lvl8pPr algn="l" defTabSz="342900" eaLnBrk="1" hangingPunct="1" indent="-342900" latinLnBrk="0" marL="2743200" rtl="0">
+      <a:lvl8pPr algn="l" defTabSz="457200" eaLnBrk="1" hangingPunct="1" indent="-228600" latinLnBrk="0" marL="3429000" rtl="0">
         <a:spcBef>
           <a:spcPct val="20000"/>
         </a:spcBef>
         <a:buFont typeface="Arial"/>
         <a:buChar char="•"/>
-        <a:defRPr kern="1200" sz="1500">
+        <a:defRPr kern="1200" sz="2000">
           <a:solidFill>
             <a:schemeClr val="tx1"/>
           </a:solidFill>
@@ -2970,13 +3109,13 @@
           <a:cs typeface="+mn-cs"/>
         </a:defRPr>
       </a:lvl8pPr>
-      <a:lvl9pPr algn="l" defTabSz="342900" eaLnBrk="1" hangingPunct="1" indent="-342900" latinLnBrk="0" marL="3086100" rtl="0">
+      <a:lvl9pPr algn="l" defTabSz="457200" eaLnBrk="1" hangingPunct="1" indent="-228600" latinLnBrk="0" marL="3886200" rtl="0">
         <a:spcBef>
           <a:spcPct val="20000"/>
         </a:spcBef>
         <a:buFont typeface="Arial"/>
         <a:buChar char="•"/>
-        <a:defRPr kern="1200" sz="1500">
+        <a:defRPr kern="1200" sz="2000">
           <a:solidFill>
             <a:schemeClr val="tx1"/>
           </a:solidFill>
@@ -2990,8 +3129,8 @@
       <a:defPPr>
         <a:defRPr lang="en-US"/>
       </a:defPPr>
-      <a:lvl1pPr algn="l" defTabSz="342900" eaLnBrk="1" hangingPunct="1" latinLnBrk="0" marL="0" rtl="0">
-        <a:defRPr kern="1200" sz="1350">
+      <a:lvl1pPr algn="l" defTabSz="457200" eaLnBrk="1" hangingPunct="1" latinLnBrk="0" marL="0" rtl="0">
+        <a:defRPr kern="1200" sz="1800">
           <a:solidFill>
             <a:schemeClr val="tx1"/>
           </a:solidFill>
@@ -3000,8 +3139,8 @@
           <a:cs typeface="+mn-cs"/>
         </a:defRPr>
       </a:lvl1pPr>
-      <a:lvl2pPr algn="l" defTabSz="342900" eaLnBrk="1" hangingPunct="1" latinLnBrk="0" marL="342900" rtl="0">
-        <a:defRPr kern="1200" sz="1350">
+      <a:lvl2pPr algn="l" defTabSz="457200" eaLnBrk="1" hangingPunct="1" latinLnBrk="0" marL="457200" rtl="0">
+        <a:defRPr kern="1200" sz="1800">
           <a:solidFill>
             <a:schemeClr val="tx1"/>
           </a:solidFill>
@@ -3010,8 +3149,8 @@
           <a:cs typeface="+mn-cs"/>
         </a:defRPr>
       </a:lvl2pPr>
-      <a:lvl3pPr algn="l" defTabSz="342900" eaLnBrk="1" hangingPunct="1" latinLnBrk="0" marL="685800" rtl="0">
-        <a:defRPr kern="1200" sz="1350">
+      <a:lvl3pPr algn="l" defTabSz="457200" eaLnBrk="1" hangingPunct="1" latinLnBrk="0" marL="914400" rtl="0">
+        <a:defRPr kern="1200" sz="1800">
           <a:solidFill>
             <a:schemeClr val="tx1"/>
           </a:solidFill>
@@ -3020,8 +3159,8 @@
           <a:cs typeface="+mn-cs"/>
         </a:defRPr>
       </a:lvl3pPr>
-      <a:lvl4pPr algn="l" defTabSz="342900" eaLnBrk="1" hangingPunct="1" latinLnBrk="0" marL="1028700" rtl="0">
-        <a:defRPr kern="1200" sz="1350">
+      <a:lvl4pPr algn="l" defTabSz="457200" eaLnBrk="1" hangingPunct="1" latinLnBrk="0" marL="1371600" rtl="0">
+        <a:defRPr kern="1200" sz="1800">
           <a:solidFill>
             <a:schemeClr val="tx1"/>
           </a:solidFill>
@@ -3030,8 +3169,8 @@
           <a:cs typeface="+mn-cs"/>
         </a:defRPr>
       </a:lvl4pPr>
-      <a:lvl5pPr algn="l" defTabSz="342900" eaLnBrk="1" hangingPunct="1" latinLnBrk="0" marL="1371600" rtl="0">
-        <a:defRPr kern="1200" sz="1350">
+      <a:lvl5pPr algn="l" defTabSz="457200" eaLnBrk="1" hangingPunct="1" latinLnBrk="0" marL="1828800" rtl="0">
+        <a:defRPr kern="1200" sz="1800">
           <a:solidFill>
             <a:schemeClr val="tx1"/>
           </a:solidFill>
@@ -3040,8 +3179,8 @@
           <a:cs typeface="+mn-cs"/>
         </a:defRPr>
       </a:lvl5pPr>
-      <a:lvl6pPr algn="l" defTabSz="342900" eaLnBrk="1" hangingPunct="1" latinLnBrk="0" marL="1714500" rtl="0">
-        <a:defRPr kern="1200" sz="1350">
+      <a:lvl6pPr algn="l" defTabSz="457200" eaLnBrk="1" hangingPunct="1" latinLnBrk="0" marL="2286000" rtl="0">
+        <a:defRPr kern="1200" sz="1800">
           <a:solidFill>
             <a:schemeClr val="tx1"/>
           </a:solidFill>
@@ -3050,8 +3189,8 @@
           <a:cs typeface="+mn-cs"/>
         </a:defRPr>
       </a:lvl6pPr>
-      <a:lvl7pPr algn="l" defTabSz="342900" eaLnBrk="1" hangingPunct="1" latinLnBrk="0" marL="2057400" rtl="0">
-        <a:defRPr kern="1200" sz="1350">
+      <a:lvl7pPr algn="l" defTabSz="457200" eaLnBrk="1" hangingPunct="1" latinLnBrk="0" marL="2743200" rtl="0">
+        <a:defRPr kern="1200" sz="1800">
           <a:solidFill>
             <a:schemeClr val="tx1"/>
           </a:solidFill>
@@ -3060,8 +3199,8 @@
           <a:cs typeface="+mn-cs"/>
         </a:defRPr>
       </a:lvl7pPr>
-      <a:lvl8pPr algn="l" defTabSz="342900" eaLnBrk="1" hangingPunct="1" latinLnBrk="0" marL="2400300" rtl="0">
-        <a:defRPr kern="1200" sz="1350">
+      <a:lvl8pPr algn="l" defTabSz="457200" eaLnBrk="1" hangingPunct="1" latinLnBrk="0" marL="3200400" rtl="0">
+        <a:defRPr kern="1200" sz="1800">
           <a:solidFill>
             <a:schemeClr val="tx1"/>
           </a:solidFill>
@@ -3070,8 +3209,8 @@
           <a:cs typeface="+mn-cs"/>
         </a:defRPr>
       </a:lvl8pPr>
-      <a:lvl9pPr algn="l" defTabSz="342900" eaLnBrk="1" hangingPunct="1" latinLnBrk="0" marL="2743200" rtl="0">
-        <a:defRPr kern="1200" sz="1350">
+      <a:lvl9pPr algn="l" defTabSz="457200" eaLnBrk="1" hangingPunct="1" latinLnBrk="0" marL="3657600" rtl="0">
+        <a:defRPr kern="1200" sz="1800">
           <a:solidFill>
             <a:schemeClr val="tx1"/>
           </a:solidFill>
@@ -3104,287 +3243,77 @@
       </p:grpSpPr>
       <p:sp>
         <p:nvSpPr>
-          <p:cNvPr id="2" name="Title 1"/>
-          <p:cNvSpPr>
-            <a:spLocks noGrp="1"/>
-          </p:cNvSpPr>
-          <p:nvPr>
-            <p:ph type="ctrTitle"/>
-          </p:nvPr>
-        </p:nvSpPr>
-        <p:spPr>
-          <a:xfrm>
-            <a:off x="685800" y="1597819"/>
-            <a:ext cx="7772400" cy="1102519"/>
-          </a:xfrm>
-        </p:spPr>
+          <p:cNvPr id="3" name="Content Placeholder 2"/>
+          <p:cNvSpPr>
+            <a:spLocks noGrp="1"/>
+          </p:cNvSpPr>
+          <p:nvPr>
+            <p:ph idx="1"/>
+          </p:nvPr>
+        </p:nvSpPr>
+        <p:spPr/>
         <p:txBody>
           <a:bodyPr/>
           <a:lstStyle/>
           <a:p>
             <a:pPr lvl="0" indent="0" marL="0">
+              <a:spcBef>
+                <a:spcPts val="3000"/>
+              </a:spcBef>
               <a:buNone/>
             </a:pPr>
             <a:r>
+              <a:rPr b="1"/>
+              <a:t>마크다운 한 벌이면 끝</a:t>
+            </a:r>
+          </a:p>
+          <a:p>
+            <a:pPr lvl="0"/>
+            <a:r>
               <a:rPr/>
-              <a:t>m2Slide 소개</a:t>
-            </a:r>
-          </a:p>
-        </p:txBody>
-      </p:sp>
-      <p:sp>
-        <p:nvSpPr>
-          <p:cNvPr id="3" name="Subtitle 2"/>
-          <p:cNvSpPr>
-            <a:spLocks noGrp="1"/>
-          </p:cNvSpPr>
-          <p:nvPr>
-            <p:ph idx="1" type="subTitle"/>
-          </p:nvPr>
-        </p:nvSpPr>
-        <p:spPr>
-          <a:xfrm>
-            <a:off x="1371600" y="2914650"/>
-            <a:ext cx="6400800" cy="1314450"/>
-          </a:xfrm>
-        </p:spPr>
-        <p:txBody>
-          <a:bodyPr/>
-          <a:lstStyle/>
-          <a:p>
-            <a:pPr lvl="0" indent="0" marL="0">
-              <a:buNone/>
-            </a:pPr>
+              <a:t>✍️ 마크다운</a:t>
+            </a:r>
+          </a:p>
+          <a:p>
+            <a:pPr lvl="1"/>
             <a:r>
               <a:rPr/>
-              <a:t>마크다운 한 벌로 슬라이드·전자책·PDF·PPTX까지</a:t>
-            </a:r>
-          </a:p>
-        </p:txBody>
-      </p:sp>
-      <p:sp>
-        <p:nvSpPr>
-          <p:cNvPr id="4" name="Date Placeholder 3"/>
-          <p:cNvSpPr>
-            <a:spLocks noGrp="1"/>
-          </p:cNvSpPr>
-          <p:nvPr>
-            <p:ph idx="10" sz="half" type="dt"/>
-          </p:nvPr>
-        </p:nvSpPr>
-        <p:spPr/>
-        <p:txBody>
-          <a:bodyPr/>
-          <a:lstStyle/>
-          <a:p>
-            <a:pPr lvl="0" indent="0" marL="0">
-              <a:buNone/>
-            </a:pPr>
+              <a:t>.md 한 벌 작성</a:t>
+            </a:r>
+          </a:p>
+          <a:p>
+            <a:pPr lvl="0"/>
             <a:r>
               <a:rPr/>
-              <a:t>May 10, 2026</a:t>
-            </a:r>
-          </a:p>
-        </p:txBody>
-      </p:sp>
-    </p:spTree>
-  </p:cSld>
-</p:sld>
-</file>
-
-<file path=ppt/slides/slide10.xml><?xml version="1.0" encoding="utf-8"?>
-<p:sld xmlns:a="http://schemas.openxmlformats.org/drawingml/2006/main" xmlns:r="http://schemas.openxmlformats.org/officeDocument/2006/relationships" xmlns:p="http://schemas.openxmlformats.org/presentationml/2006/main">
-  <p:cSld>
-    <p:spTree>
-      <p:nvGrpSpPr>
-        <p:cNvPr id="1" name=""/>
-        <p:cNvGrpSpPr/>
-        <p:nvPr/>
-      </p:nvGrpSpPr>
-      <p:grpSpPr>
-        <a:xfrm>
-          <a:off x="0" y="0"/>
-          <a:ext cx="0" cy="0"/>
-          <a:chOff x="0" y="0"/>
-          <a:chExt cx="0" cy="0"/>
-        </a:xfrm>
-      </p:grpSpPr>
-      <p:sp>
-        <p:nvSpPr>
-          <p:cNvPr id="3" name="Content Placeholder 2"/>
-          <p:cNvSpPr>
-            <a:spLocks noGrp="1"/>
-          </p:cNvSpPr>
-          <p:nvPr>
-            <p:ph idx="1"/>
-          </p:nvPr>
-        </p:nvSpPr>
-        <p:spPr/>
-        <p:txBody>
-          <a:bodyPr/>
-          <a:lstStyle/>
-          <a:p>
-            <a:pPr lvl="0" indent="0" marL="1270000">
-              <a:buNone/>
-            </a:pPr>
-            <a:r>
-              <a:rPr sz="2000"/>
-              <a:t>Chapter Mode·내장 컴포넌트·저작 파이프라인은 </a:t>
-            </a:r>
-            <a:r>
-              <a:rPr sz="2000" b="1"/>
-              <a:t>m2slide Showcase</a:t>
-            </a:r>
-            <a:r>
-              <a:rPr sz="2000"/>
-              <a:t>에서 실습으로</a:t>
-            </a:r>
-          </a:p>
-        </p:txBody>
-      </p:sp>
-    </p:spTree>
-  </p:cSld>
-</p:sld>
-</file>
-
-<file path=ppt/slides/slide11.xml><?xml version="1.0" encoding="utf-8"?>
-<p:sld xmlns:a="http://schemas.openxmlformats.org/drawingml/2006/main" xmlns:r="http://schemas.openxmlformats.org/officeDocument/2006/relationships" xmlns:p="http://schemas.openxmlformats.org/presentationml/2006/main">
-  <p:cSld>
-    <p:spTree>
-      <p:nvGrpSpPr>
-        <p:cNvPr id="1" name=""/>
-        <p:cNvGrpSpPr/>
-        <p:nvPr/>
-      </p:nvGrpSpPr>
-      <p:grpSpPr>
-        <a:xfrm>
-          <a:off x="0" y="0"/>
-          <a:ext cx="0" cy="0"/>
-          <a:chOff x="0" y="0"/>
-          <a:chExt cx="0" cy="0"/>
-        </a:xfrm>
-      </p:grpSpPr>
-      <p:sp>
-        <p:nvSpPr>
-          <p:cNvPr id="2" name="Title 1"/>
-          <p:cNvSpPr>
-            <a:spLocks noGrp="1"/>
-          </p:cNvSpPr>
-          <p:nvPr>
-            <p:ph type="title"/>
-          </p:nvPr>
-        </p:nvSpPr>
-        <p:spPr/>
-        <p:txBody>
-          <a:bodyPr/>
-          <a:lstStyle/>
-          <a:p>
-            <a:pPr lvl="0" indent="0" marL="0">
-              <a:buNone/>
-            </a:pPr>
-            <a:r>
-              <a:rPr>
-                <a:hlinkClick r:id="rId2"/>
-              </a:rPr>
-              <a:t>1. m2Slide란?</a:t>
-            </a:r>
-          </a:p>
-        </p:txBody>
-      </p:sp>
-    </p:spTree>
-  </p:cSld>
-</p:sld>
-</file>
-
-<file path=ppt/slides/slide12.xml><?xml version="1.0" encoding="utf-8"?>
-<p:sld xmlns:a="http://schemas.openxmlformats.org/drawingml/2006/main" xmlns:r="http://schemas.openxmlformats.org/officeDocument/2006/relationships" xmlns:p="http://schemas.openxmlformats.org/presentationml/2006/main">
-  <p:cSld>
-    <p:spTree>
-      <p:nvGrpSpPr>
-        <p:cNvPr id="1" name=""/>
-        <p:cNvGrpSpPr/>
-        <p:nvPr/>
-      </p:nvGrpSpPr>
-      <p:grpSpPr>
-        <a:xfrm>
-          <a:off x="0" y="0"/>
-          <a:ext cx="0" cy="0"/>
-          <a:chOff x="0" y="0"/>
-          <a:chExt cx="0" cy="0"/>
-        </a:xfrm>
-      </p:grpSpPr>
-      <p:sp>
-        <p:nvSpPr>
-          <p:cNvPr id="2" name="Title 1"/>
-          <p:cNvSpPr>
-            <a:spLocks noGrp="1"/>
-          </p:cNvSpPr>
-          <p:nvPr>
-            <p:ph type="title"/>
-          </p:nvPr>
-        </p:nvSpPr>
-        <p:spPr/>
-        <p:txBody>
-          <a:bodyPr/>
-          <a:lstStyle/>
-          <a:p>
-            <a:pPr lvl="0" indent="0" marL="0">
-              <a:buNone/>
-            </a:pPr>
-            <a:r>
-              <a:rPr>
-                <a:hlinkClick r:id="rId2"/>
-              </a:rPr>
-              <a:t>2. 왜 m2Slide인가</a:t>
-            </a:r>
-          </a:p>
-        </p:txBody>
-      </p:sp>
-    </p:spTree>
-  </p:cSld>
-</p:sld>
-</file>
-
-<file path=ppt/slides/slide13.xml><?xml version="1.0" encoding="utf-8"?>
-<p:sld xmlns:a="http://schemas.openxmlformats.org/drawingml/2006/main" xmlns:r="http://schemas.openxmlformats.org/officeDocument/2006/relationships" xmlns:p="http://schemas.openxmlformats.org/presentationml/2006/main">
-  <p:cSld>
-    <p:spTree>
-      <p:nvGrpSpPr>
-        <p:cNvPr id="1" name=""/>
-        <p:cNvGrpSpPr/>
-        <p:nvPr/>
-      </p:nvGrpSpPr>
-      <p:grpSpPr>
-        <a:xfrm>
-          <a:off x="0" y="0"/>
-          <a:ext cx="0" cy="0"/>
-          <a:chOff x="0" y="0"/>
-          <a:chExt cx="0" cy="0"/>
-        </a:xfrm>
-      </p:grpSpPr>
-      <p:sp>
-        <p:nvSpPr>
-          <p:cNvPr id="2" name="Title 1"/>
-          <p:cNvSpPr>
-            <a:spLocks noGrp="1"/>
-          </p:cNvSpPr>
-          <p:nvPr>
-            <p:ph type="title"/>
-          </p:nvPr>
-        </p:nvSpPr>
-        <p:spPr/>
-        <p:txBody>
-          <a:bodyPr/>
-          <a:lstStyle/>
-          <a:p>
-            <a:pPr lvl="0" indent="0" marL="0">
-              <a:buNone/>
-            </a:pPr>
-            <a:r>
-              <a:rPr>
-                <a:hlinkClick r:id="rId2"/>
-              </a:rPr>
-              <a:t>3. 30초 시작</a:t>
+              <a:t>⚙️ m2slide.sh</a:t>
+            </a:r>
+          </a:p>
+          <a:p>
+            <a:pPr lvl="1"/>
+            <a:r>
+              <a:rPr/>
+              <a:t>명령 한 줄</a:t>
+            </a:r>
+          </a:p>
+          <a:p>
+            <a:pPr lvl="0"/>
+            <a:r>
+              <a:rPr/>
+              <a:t>🎁 4종 산출물</a:t>
+            </a:r>
+          </a:p>
+          <a:p>
+            <a:pPr lvl="1"/>
+            <a:r>
+              <a:rPr/>
+              <a:t>HTML · EPUB</a:t>
+            </a:r>
+          </a:p>
+          <a:p>
+            <a:pPr lvl="1"/>
+            <a:r>
+              <a:rPr/>
+              <a:t>PDF · PPTX</a:t>
             </a:r>
           </a:p>
         </p:txBody>
@@ -3413,12 +3342,12 @@
       </p:grpSpPr>
       <p:sp>
         <p:nvSpPr>
-          <p:cNvPr id="2" name="Title 1"/>
-          <p:cNvSpPr>
-            <a:spLocks noGrp="1"/>
-          </p:cNvSpPr>
-          <p:nvPr>
-            <p:ph type="title"/>
+          <p:cNvPr id="4" name="Text Placeholder 3"/>
+          <p:cNvSpPr>
+            <a:spLocks noGrp="1"/>
+          </p:cNvSpPr>
+          <p:nvPr>
+            <p:ph idx="2" sz="half" type="body"/>
           </p:nvPr>
         </p:nvSpPr>
         <p:spPr/>
@@ -3427,82 +3356,13 @@
           <a:lstStyle/>
           <a:p>
             <a:pPr lvl="0" indent="0" marL="0">
+              <a:spcBef>
+                <a:spcPts val="3000"/>
+              </a:spcBef>
               <a:buNone/>
             </a:pPr>
             <a:r>
-              <a:rPr/>
-              <a:t>마크다운 한 벌이면 끝</a:t>
-            </a:r>
-          </a:p>
-        </p:txBody>
-      </p:sp>
-      <p:sp>
-        <p:nvSpPr>
-          <p:cNvPr id="3" name="Content Placeholder 2"/>
-          <p:cNvSpPr>
-            <a:spLocks noGrp="1"/>
-          </p:cNvSpPr>
-          <p:nvPr>
-            <p:ph idx="1"/>
-          </p:nvPr>
-        </p:nvSpPr>
-        <p:spPr/>
-        <p:txBody>
-          <a:bodyPr/>
-          <a:lstStyle/>
-          <a:p>
-            <a:pPr lvl="0" indent="0" marL="0">
-              <a:buNone/>
-            </a:pPr>
-            <a:r>
-              <a:rPr/>
-              <a:t>::: htmlart process * ✍️ 마크다운 - .md 한 벌 작성 * ⚙️ m2slide.sh - 명령 한 줄 * 🎁 4종 산출물 - HTML · EPUB - PDF · PPTX :::</a:t>
-            </a:r>
-          </a:p>
-        </p:txBody>
-      </p:sp>
-    </p:spTree>
-  </p:cSld>
-</p:sld>
-</file>
-
-<file path=ppt/slides/slide3.xml><?xml version="1.0" encoding="utf-8"?>
-<p:sld xmlns:a="http://schemas.openxmlformats.org/drawingml/2006/main" xmlns:r="http://schemas.openxmlformats.org/officeDocument/2006/relationships" xmlns:p="http://schemas.openxmlformats.org/presentationml/2006/main">
-  <p:cSld>
-    <p:spTree>
-      <p:nvGrpSpPr>
-        <p:cNvPr id="1" name=""/>
-        <p:cNvGrpSpPr/>
-        <p:nvPr/>
-      </p:nvGrpSpPr>
-      <p:grpSpPr>
-        <a:xfrm>
-          <a:off x="0" y="0"/>
-          <a:ext cx="0" cy="0"/>
-          <a:chOff x="0" y="0"/>
-          <a:chExt cx="0" cy="0"/>
-        </a:xfrm>
-      </p:grpSpPr>
-      <p:sp>
-        <p:nvSpPr>
-          <p:cNvPr id="2" name="Title 1"/>
-          <p:cNvSpPr>
-            <a:spLocks noGrp="1"/>
-          </p:cNvSpPr>
-          <p:nvPr>
-            <p:ph type="title"/>
-          </p:nvPr>
-        </p:nvSpPr>
-        <p:spPr/>
-        <p:txBody>
-          <a:bodyPr/>
-          <a:lstStyle/>
-          <a:p>
-            <a:pPr lvl="0" indent="0" marL="0">
-              <a:buNone/>
-            </a:pPr>
-            <a:r>
-              <a:rPr/>
+              <a:rPr b="1"/>
               <a:t>한 번 쓰고, 네 가지로 낸다</a:t>
             </a:r>
           </a:p>
@@ -3519,8 +3379,8 @@
           </p:nvPr>
         </p:nvGraphicFramePr>
         <p:xfrm>
-          <a:off x="457200" y="1193800"/>
-          <a:ext cx="8229600" cy="3390900"/>
+          <a:off x="3568700" y="266700"/>
+          <a:ext cx="5105400" cy="5842000"/>
         </p:xfrm>
         <a:graphic>
           <a:graphicData uri="http://schemas.openxmlformats.org/drawingml/2006/table">
@@ -3529,9 +3389,9 @@
                 <a:tableStyleId>{5C22544A-7EE6-4342-B048-85BDC9FD1C3A}</a:tableStyleId>
               </a:tblPr>
               <a:tblGrid>
-                <a:gridCol w="2743200"/>
-                <a:gridCol w="2743200"/>
-                <a:gridCol w="2743200"/>
+                <a:gridCol w="1701800"/>
+                <a:gridCol w="1701800"/>
+                <a:gridCol w="1701800"/>
               </a:tblGrid>
               <a:tr h="0">
                 <a:tc>
@@ -3786,6 +3646,133 @@
 </p:sld>
 </file>
 
+<file path=ppt/slides/slide3.xml><?xml version="1.0" encoding="utf-8"?>
+<p:sld xmlns:a="http://schemas.openxmlformats.org/drawingml/2006/main" xmlns:r="http://schemas.openxmlformats.org/officeDocument/2006/relationships" xmlns:p="http://schemas.openxmlformats.org/presentationml/2006/main">
+  <p:cSld>
+    <p:spTree>
+      <p:nvGrpSpPr>
+        <p:cNvPr id="1" name=""/>
+        <p:cNvGrpSpPr/>
+        <p:nvPr/>
+      </p:nvGrpSpPr>
+      <p:grpSpPr>
+        <a:xfrm>
+          <a:off x="0" y="0"/>
+          <a:ext cx="0" cy="0"/>
+          <a:chOff x="0" y="0"/>
+          <a:chExt cx="0" cy="0"/>
+        </a:xfrm>
+      </p:grpSpPr>
+      <p:sp>
+        <p:nvSpPr>
+          <p:cNvPr id="3" name="Content Placeholder 2"/>
+          <p:cNvSpPr>
+            <a:spLocks noGrp="1"/>
+          </p:cNvSpPr>
+          <p:nvPr>
+            <p:ph idx="1"/>
+          </p:nvPr>
+        </p:nvSpPr>
+        <p:spPr/>
+        <p:txBody>
+          <a:bodyPr/>
+          <a:lstStyle/>
+          <a:p>
+            <a:pPr lvl="0"/>
+            <a:r>
+              <a:rPr>
+                <a:latin typeface="Courier"/>
+              </a:rPr>
+              <a:t>.md</a:t>
+            </a:r>
+            <a:r>
+              <a:rPr/>
+              <a:t> 하나가 모든 형식의 원본(SSOT)</a:t>
+            </a:r>
+          </a:p>
+          <a:p>
+            <a:pPr lvl="0" indent="0" marL="0">
+              <a:spcBef>
+                <a:spcPts val="3000"/>
+              </a:spcBef>
+              <a:buNone/>
+            </a:pPr>
+            <a:r>
+              <a:rPr b="1"/>
+              <a:t>도구와 씨름 끝, 콘텐츠에 집중</a:t>
+            </a:r>
+          </a:p>
+          <a:p>
+            <a:pPr lvl="0"/>
+            <a:r>
+              <a:rPr b="1"/>
+              <a:t>기존 방식</a:t>
+            </a:r>
+            <a:r>
+              <a:rPr/>
+              <a:t> / 도구가 주인공</a:t>
+            </a:r>
+          </a:p>
+          <a:p>
+            <a:pPr lvl="1"/>
+            <a:r>
+              <a:rPr/>
+              <a:t>슬라이드·전자책·PDF 도구 따로따로</a:t>
+            </a:r>
+          </a:p>
+          <a:p>
+            <a:pPr lvl="1"/>
+            <a:r>
+              <a:rPr/>
+              <a:t>바이너리 포맷 — diff·리뷰 불가</a:t>
+            </a:r>
+          </a:p>
+          <a:p>
+            <a:pPr lvl="1"/>
+            <a:r>
+              <a:rPr/>
+              <a:t>디자인 맞추다 시간 소진</a:t>
+            </a:r>
+          </a:p>
+          <a:p>
+            <a:pPr lvl="0"/>
+            <a:r>
+              <a:rPr b="1"/>
+              <a:t>m2Slide</a:t>
+            </a:r>
+            <a:r>
+              <a:rPr/>
+              <a:t> / 콘텐츠가 주인공</a:t>
+            </a:r>
+          </a:p>
+          <a:p>
+            <a:pPr lvl="1"/>
+            <a:r>
+              <a:rPr/>
+              <a:t>마크다운 하나로 전부 생성</a:t>
+            </a:r>
+          </a:p>
+          <a:p>
+            <a:pPr lvl="1"/>
+            <a:r>
+              <a:rPr/>
+              <a:t>Git으로 버전 관리·협업</a:t>
+            </a:r>
+          </a:p>
+          <a:p>
+            <a:pPr lvl="1"/>
+            <a:r>
+              <a:rPr/>
+              <a:t>theme 한 줄로 디자인 교체</a:t>
+            </a:r>
+          </a:p>
+        </p:txBody>
+      </p:sp>
+    </p:spTree>
+  </p:cSld>
+</p:sld>
+</file>
+
 <file path=ppt/slides/slide4.xml><?xml version="1.0" encoding="utf-8"?>
 <p:sld xmlns:a="http://schemas.openxmlformats.org/drawingml/2006/main" xmlns:r="http://schemas.openxmlformats.org/officeDocument/2006/relationships" xmlns:p="http://schemas.openxmlformats.org/presentationml/2006/main">
   <p:cSld>
@@ -3818,16 +3805,78 @@
           <a:bodyPr/>
           <a:lstStyle/>
           <a:p>
+            <a:pPr lvl="0" indent="0" marL="0">
+              <a:spcBef>
+                <a:spcPts val="3000"/>
+              </a:spcBef>
+              <a:buNone/>
+            </a:pPr>
+            <a:r>
+              <a:rPr b="1"/>
+              <a:t>네 가지 이유</a:t>
+            </a:r>
+          </a:p>
+          <a:p>
             <a:pPr lvl="0"/>
             <a:r>
-              <a:rPr>
-                <a:latin typeface="Courier"/>
-              </a:rPr>
-              <a:t>.md</a:t>
-            </a:r>
-            <a:r>
               <a:rPr/>
-              <a:t> 하나가 모든 형식의 원본(SSOT)</a:t>
+              <a:t>m2Slide</a:t>
+            </a:r>
+          </a:p>
+          <a:p>
+            <a:pPr lvl="0"/>
+            <a:r>
+              <a:rPr/>
+              <a:t>단일 SSOT</a:t>
+            </a:r>
+          </a:p>
+          <a:p>
+            <a:pPr lvl="1"/>
+            <a:r>
+              <a:rPr/>
+              <a:t>.md 하나가 원본</a:t>
+            </a:r>
+          </a:p>
+          <a:p>
+            <a:pPr lvl="0"/>
+            <a:r>
+              <a:rPr/>
+              <a:t>Git 친화</a:t>
+            </a:r>
+          </a:p>
+          <a:p>
+            <a:pPr lvl="1"/>
+            <a:r>
+              <a:rPr/>
+              <a:t>diff·리뷰·협업</a:t>
+            </a:r>
+          </a:p>
+          <a:p>
+            <a:pPr lvl="0"/>
+            <a:r>
+              <a:rPr/>
+              <a:t>확장 자유</a:t>
+            </a:r>
+          </a:p>
+          <a:p>
+            <a:pPr lvl="1"/>
+            <a:r>
+              <a:rPr/>
+              <a:t>theme·layout·컴포넌트</a:t>
+            </a:r>
+          </a:p>
+          <a:p>
+            <a:pPr lvl="0"/>
+            <a:r>
+              <a:rPr/>
+              <a:t>즉시 시작</a:t>
+            </a:r>
+          </a:p>
+          <a:p>
+            <a:pPr lvl="1"/>
+            <a:r>
+              <a:rPr/>
+              <a:t>마크다운만 알면 끝</a:t>
             </a:r>
           </a:p>
         </p:txBody>
@@ -3856,12 +3905,12 @@
       </p:grpSpPr>
       <p:sp>
         <p:nvSpPr>
-          <p:cNvPr id="2" name="Title 1"/>
-          <p:cNvSpPr>
-            <a:spLocks noGrp="1"/>
-          </p:cNvSpPr>
-          <p:nvPr>
-            <p:ph type="title"/>
+          <p:cNvPr id="3" name="Content Placeholder 2"/>
+          <p:cNvSpPr>
+            <a:spLocks noGrp="1"/>
+          </p:cNvSpPr>
+          <p:nvPr>
+            <p:ph idx="1"/>
           </p:nvPr>
         </p:nvSpPr>
         <p:spPr/>
@@ -3870,52 +3919,138 @@
           <a:lstStyle/>
           <a:p>
             <a:pPr lvl="0" indent="0" marL="0">
+              <a:spcBef>
+                <a:spcPts val="3000"/>
+              </a:spcBef>
               <a:buNone/>
             </a:pPr>
             <a:r>
+              <a:rPr b="1"/>
+              <a:t>발표가 편해진다</a:t>
+            </a:r>
+          </a:p>
+          <a:p>
+            <a:pPr lvl="0"/>
+            <a:r>
+              <a:rPr b="1"/>
+              <a:t>Markmap 목차</a:t>
+            </a:r>
+            <a:r>
               <a:rPr/>
-              <a:t>도구와 씨름 끝, 콘텐츠에 집중</a:t>
-            </a:r>
-          </a:p>
-        </p:txBody>
-      </p:sp>
-      <p:sp>
-        <p:nvSpPr>
-          <p:cNvPr id="3" name="Content Placeholder 2"/>
-          <p:cNvSpPr>
-            <a:spLocks noGrp="1"/>
-          </p:cNvSpPr>
-          <p:nvPr>
-            <p:ph idx="1"/>
-          </p:nvPr>
-        </p:nvSpPr>
-        <p:spPr/>
-        <p:txBody>
-          <a:bodyPr/>
-          <a:lstStyle/>
+              <a:t> — 클릭 가능한 마인드맵 자동 생성</a:t>
+            </a:r>
+          </a:p>
+          <a:p>
+            <a:pPr lvl="0"/>
+            <a:r>
+              <a:rPr b="1"/>
+              <a:t>계층 네비게이션</a:t>
+            </a:r>
+            <a:r>
+              <a:rPr/>
+              <a:t> — 챕터 간 이동 자동 연결</a:t>
+            </a:r>
+          </a:p>
+          <a:p>
+            <a:pPr lvl="0"/>
+            <a:r>
+              <a:rPr b="1"/>
+              <a:t>단계별 등장</a:t>
+            </a:r>
+            <a:r>
+              <a:rPr/>
+              <a:t> — </a:t>
+            </a:r>
+            <a:r>
+              <a:rPr>
+                <a:latin typeface="Courier"/>
+              </a:rPr>
+              <a:t>{.fragment}</a:t>
+            </a:r>
+            <a:r>
+              <a:rPr/>
+              <a:t> 한 토큰이면 끝</a:t>
+            </a:r>
+          </a:p>
+          <a:p>
+            <a:pPr lvl="0"/>
+            <a:r>
+              <a:rPr b="1"/>
+              <a:t>차트·수식·mermaid·3D</a:t>
+            </a:r>
+            <a:r>
+              <a:rPr/>
+              <a:t> — 펜스드 블록으로 바로 삽입</a:t>
+            </a:r>
+          </a:p>
           <a:p>
             <a:pPr lvl="0" indent="0" marL="0">
+              <a:spcBef>
+                <a:spcPts val="3000"/>
+              </a:spcBef>
               <a:buNone/>
             </a:pPr>
             <a:r>
+              <a:rPr b="1"/>
+              <a:t>빌드 한 줄</a:t>
+            </a:r>
+          </a:p>
+          <a:p>
+            <a:pPr lvl="0" indent="0">
+              <a:buNone/>
+            </a:pPr>
+            <a:r>
+              <a:rPr>
+                <a:latin typeface="Courier"/>
+              </a:rPr>
+              <a:t>./m2slide.sh m2Slide          </a:t>
+            </a:r>
+            <a:r>
+              <a:rPr i="1">
+                <a:solidFill>
+                  <a:srgbClr val="60A0B0"/>
+                </a:solidFill>
+                <a:latin typeface="Courier"/>
+              </a:rPr>
+              <a:t># HTML 슬라이드</a:t>
+            </a:r>
+            <a:br/>
+            <a:r>
+              <a:rPr>
+                <a:latin typeface="Courier"/>
+              </a:rPr>
+              <a:t>./m2slide.sh m2Slide </a:t>
+            </a:r>
+            <a:r>
+              <a:rPr>
+                <a:solidFill>
+                  <a:srgbClr val="7D9029"/>
+                </a:solidFill>
+                <a:latin typeface="Courier"/>
+              </a:rPr>
+              <a:t>--epub</a:t>
+            </a:r>
+            <a:r>
+              <a:rPr>
+                <a:latin typeface="Courier"/>
+              </a:rPr>
+              <a:t>   </a:t>
+            </a:r>
+            <a:r>
+              <a:rPr i="1">
+                <a:solidFill>
+                  <a:srgbClr val="60A0B0"/>
+                </a:solidFill>
+                <a:latin typeface="Courier"/>
+              </a:rPr>
+              <a:t># + 전자책</a:t>
+            </a:r>
+          </a:p>
+          <a:p>
+            <a:pPr lvl="0"/>
+            <a:r>
               <a:rPr/>
-              <a:t>::: htmlart compare * </a:t>
-            </a:r>
-            <a:r>
-              <a:rPr b="1"/>
-              <a:t>기존 방식</a:t>
-            </a:r>
-            <a:r>
-              <a:rPr/>
-              <a:t> / 도구가 주인공 - 슬라이드·전자책·PDF 도구 따로따로 - 바이너리 포맷 — diff·리뷰 불가 - 디자인 맞추다 시간 소진 * </a:t>
-            </a:r>
-            <a:r>
-              <a:rPr b="1"/>
-              <a:t>m2Slide</a:t>
-            </a:r>
-            <a:r>
-              <a:rPr/>
-              <a:t> / 콘텐츠가 주인공 - 마크다운 하나로 전부 생성 - Git으로 버전 관리·협업 - theme 한 줄로 디자인 교체 :::</a:t>
+              <a:t>마크다운만 알면 누구나 즉시 시작</a:t>
             </a:r>
           </a:p>
         </p:txBody>
@@ -3944,12 +4079,12 @@
       </p:grpSpPr>
       <p:sp>
         <p:nvSpPr>
-          <p:cNvPr id="2" name="Title 1"/>
-          <p:cNvSpPr>
-            <a:spLocks noGrp="1"/>
-          </p:cNvSpPr>
-          <p:nvPr>
-            <p:ph type="title"/>
+          <p:cNvPr id="4" name="Text Placeholder 3"/>
+          <p:cNvSpPr>
+            <a:spLocks noGrp="1"/>
+          </p:cNvSpPr>
+          <p:nvPr>
+            <p:ph idx="2" sz="half" type="body"/>
           </p:nvPr>
         </p:nvSpPr>
         <p:spPr/>
@@ -3958,320 +4093,13 @@
           <a:lstStyle/>
           <a:p>
             <a:pPr lvl="0" indent="0" marL="0">
+              <a:spcBef>
+                <a:spcPts val="3000"/>
+              </a:spcBef>
               <a:buNone/>
             </a:pPr>
             <a:r>
-              <a:rPr/>
-              <a:t>네 가지 이유</a:t>
-            </a:r>
-          </a:p>
-        </p:txBody>
-      </p:sp>
-      <p:sp>
-        <p:nvSpPr>
-          <p:cNvPr id="3" name="Content Placeholder 2"/>
-          <p:cNvSpPr>
-            <a:spLocks noGrp="1"/>
-          </p:cNvSpPr>
-          <p:nvPr>
-            <p:ph idx="1"/>
-          </p:nvPr>
-        </p:nvSpPr>
-        <p:spPr/>
-        <p:txBody>
-          <a:bodyPr/>
-          <a:lstStyle/>
-          <a:p>
-            <a:pPr lvl="0" indent="0" marL="0">
-              <a:buNone/>
-            </a:pPr>
-            <a:r>
-              <a:rPr/>
-              <a:t>::: htmlart radial * m2Slide * 단일 SSOT - .md 하나가 원본 * Git 친화 - diff·리뷰·협업 * 확장 자유 - theme·layout·컴포넌트 * 즉시 시작 - 마크다운만 알면 끝 :::</a:t>
-            </a:r>
-          </a:p>
-        </p:txBody>
-      </p:sp>
-    </p:spTree>
-  </p:cSld>
-</p:sld>
-</file>
-
-<file path=ppt/slides/slide7.xml><?xml version="1.0" encoding="utf-8"?>
-<p:sld xmlns:a="http://schemas.openxmlformats.org/drawingml/2006/main" xmlns:r="http://schemas.openxmlformats.org/officeDocument/2006/relationships" xmlns:p="http://schemas.openxmlformats.org/presentationml/2006/main">
-  <p:cSld>
-    <p:spTree>
-      <p:nvGrpSpPr>
-        <p:cNvPr id="1" name=""/>
-        <p:cNvGrpSpPr/>
-        <p:nvPr/>
-      </p:nvGrpSpPr>
-      <p:grpSpPr>
-        <a:xfrm>
-          <a:off x="0" y="0"/>
-          <a:ext cx="0" cy="0"/>
-          <a:chOff x="0" y="0"/>
-          <a:chExt cx="0" cy="0"/>
-        </a:xfrm>
-      </p:grpSpPr>
-      <p:sp>
-        <p:nvSpPr>
-          <p:cNvPr id="2" name="Title 1"/>
-          <p:cNvSpPr>
-            <a:spLocks noGrp="1"/>
-          </p:cNvSpPr>
-          <p:nvPr>
-            <p:ph type="title"/>
-          </p:nvPr>
-        </p:nvSpPr>
-        <p:spPr/>
-        <p:txBody>
-          <a:bodyPr/>
-          <a:lstStyle/>
-          <a:p>
-            <a:pPr lvl="0" indent="0" marL="0">
-              <a:buNone/>
-            </a:pPr>
-            <a:r>
-              <a:rPr/>
-              <a:t>발표가 편해진다</a:t>
-            </a:r>
-          </a:p>
-        </p:txBody>
-      </p:sp>
-      <p:sp>
-        <p:nvSpPr>
-          <p:cNvPr id="3" name="Content Placeholder 2"/>
-          <p:cNvSpPr>
-            <a:spLocks noGrp="1"/>
-          </p:cNvSpPr>
-          <p:nvPr>
-            <p:ph idx="1"/>
-          </p:nvPr>
-        </p:nvSpPr>
-        <p:spPr/>
-        <p:txBody>
-          <a:bodyPr/>
-          <a:lstStyle/>
-          <a:p>
-            <a:pPr lvl="0"/>
-            <a:r>
               <a:rPr b="1"/>
-              <a:t>Markmap 목차</a:t>
-            </a:r>
-            <a:r>
-              <a:rPr/>
-              <a:t> — 클릭 가능한 마인드맵 자동 생성</a:t>
-            </a:r>
-          </a:p>
-          <a:p>
-            <a:pPr lvl="0"/>
-            <a:r>
-              <a:rPr b="1"/>
-              <a:t>계층 네비게이션</a:t>
-            </a:r>
-            <a:r>
-              <a:rPr/>
-              <a:t> — 챕터 간 이동 자동 연결</a:t>
-            </a:r>
-          </a:p>
-          <a:p>
-            <a:pPr lvl="0"/>
-            <a:r>
-              <a:rPr b="1"/>
-              <a:t>단계별 등장</a:t>
-            </a:r>
-            <a:r>
-              <a:rPr/>
-              <a:t> — </a:t>
-            </a:r>
-            <a:r>
-              <a:rPr>
-                <a:latin typeface="Courier"/>
-              </a:rPr>
-              <a:t>{.fragment}</a:t>
-            </a:r>
-            <a:r>
-              <a:rPr/>
-              <a:t> 한 토큰이면 끝</a:t>
-            </a:r>
-          </a:p>
-          <a:p>
-            <a:pPr lvl="0"/>
-            <a:r>
-              <a:rPr b="1"/>
-              <a:t>차트·수식·mermaid·3D</a:t>
-            </a:r>
-            <a:r>
-              <a:rPr/>
-              <a:t> — 펜스드 블록으로 바로 삽입</a:t>
-            </a:r>
-          </a:p>
-        </p:txBody>
-      </p:sp>
-    </p:spTree>
-  </p:cSld>
-</p:sld>
-</file>
-
-<file path=ppt/slides/slide8.xml><?xml version="1.0" encoding="utf-8"?>
-<p:sld xmlns:a="http://schemas.openxmlformats.org/drawingml/2006/main" xmlns:r="http://schemas.openxmlformats.org/officeDocument/2006/relationships" xmlns:p="http://schemas.openxmlformats.org/presentationml/2006/main">
-  <p:cSld>
-    <p:spTree>
-      <p:nvGrpSpPr>
-        <p:cNvPr id="1" name=""/>
-        <p:cNvGrpSpPr/>
-        <p:nvPr/>
-      </p:nvGrpSpPr>
-      <p:grpSpPr>
-        <a:xfrm>
-          <a:off x="0" y="0"/>
-          <a:ext cx="0" cy="0"/>
-          <a:chOff x="0" y="0"/>
-          <a:chExt cx="0" cy="0"/>
-        </a:xfrm>
-      </p:grpSpPr>
-      <p:sp>
-        <p:nvSpPr>
-          <p:cNvPr id="2" name="Title 1"/>
-          <p:cNvSpPr>
-            <a:spLocks noGrp="1"/>
-          </p:cNvSpPr>
-          <p:nvPr>
-            <p:ph type="title"/>
-          </p:nvPr>
-        </p:nvSpPr>
-        <p:spPr/>
-        <p:txBody>
-          <a:bodyPr/>
-          <a:lstStyle/>
-          <a:p>
-            <a:pPr lvl="0" indent="0" marL="0">
-              <a:buNone/>
-            </a:pPr>
-            <a:r>
-              <a:rPr/>
-              <a:t>빌드 한 줄</a:t>
-            </a:r>
-          </a:p>
-        </p:txBody>
-      </p:sp>
-      <p:sp>
-        <p:nvSpPr>
-          <p:cNvPr id="3" name="Content Placeholder 2"/>
-          <p:cNvSpPr>
-            <a:spLocks noGrp="1"/>
-          </p:cNvSpPr>
-          <p:nvPr>
-            <p:ph idx="1"/>
-          </p:nvPr>
-        </p:nvSpPr>
-        <p:spPr/>
-        <p:txBody>
-          <a:bodyPr/>
-          <a:lstStyle/>
-          <a:p>
-            <a:pPr lvl="0" indent="0">
-              <a:buNone/>
-            </a:pPr>
-            <a:r>
-              <a:rPr>
-                <a:latin typeface="Courier"/>
-              </a:rPr>
-              <a:t>./m2slide.sh m2Slide          </a:t>
-            </a:r>
-            <a:r>
-              <a:rPr i="1">
-                <a:solidFill>
-                  <a:srgbClr val="60A0B0"/>
-                </a:solidFill>
-                <a:latin typeface="Courier"/>
-              </a:rPr>
-              <a:t># HTML 슬라이드</a:t>
-            </a:r>
-            <a:br/>
-            <a:r>
-              <a:rPr>
-                <a:latin typeface="Courier"/>
-              </a:rPr>
-              <a:t>./m2slide.sh m2Slide </a:t>
-            </a:r>
-            <a:r>
-              <a:rPr>
-                <a:solidFill>
-                  <a:srgbClr val="7D9029"/>
-                </a:solidFill>
-                <a:latin typeface="Courier"/>
-              </a:rPr>
-              <a:t>--epub</a:t>
-            </a:r>
-            <a:r>
-              <a:rPr>
-                <a:latin typeface="Courier"/>
-              </a:rPr>
-              <a:t>   </a:t>
-            </a:r>
-            <a:r>
-              <a:rPr i="1">
-                <a:solidFill>
-                  <a:srgbClr val="60A0B0"/>
-                </a:solidFill>
-                <a:latin typeface="Courier"/>
-              </a:rPr>
-              <a:t># + 전자책</a:t>
-            </a:r>
-          </a:p>
-          <a:p>
-            <a:pPr lvl="0"/>
-            <a:r>
-              <a:rPr/>
-              <a:t>마크다운만 알면 누구나 즉시 시작</a:t>
-            </a:r>
-          </a:p>
-        </p:txBody>
-      </p:sp>
-    </p:spTree>
-  </p:cSld>
-</p:sld>
-</file>
-
-<file path=ppt/slides/slide9.xml><?xml version="1.0" encoding="utf-8"?>
-<p:sld xmlns:a="http://schemas.openxmlformats.org/drawingml/2006/main" xmlns:r="http://schemas.openxmlformats.org/officeDocument/2006/relationships" xmlns:p="http://schemas.openxmlformats.org/presentationml/2006/main">
-  <p:cSld>
-    <p:spTree>
-      <p:nvGrpSpPr>
-        <p:cNvPr id="1" name=""/>
-        <p:cNvGrpSpPr/>
-        <p:nvPr/>
-      </p:nvGrpSpPr>
-      <p:grpSpPr>
-        <a:xfrm>
-          <a:off x="0" y="0"/>
-          <a:ext cx="0" cy="0"/>
-          <a:chOff x="0" y="0"/>
-          <a:chExt cx="0" cy="0"/>
-        </a:xfrm>
-      </p:grpSpPr>
-      <p:sp>
-        <p:nvSpPr>
-          <p:cNvPr id="2" name="Title 1"/>
-          <p:cNvSpPr>
-            <a:spLocks noGrp="1"/>
-          </p:cNvSpPr>
-          <p:nvPr>
-            <p:ph type="title"/>
-          </p:nvPr>
-        </p:nvSpPr>
-        <p:spPr/>
-        <p:txBody>
-          <a:bodyPr/>
-          <a:lstStyle/>
-          <a:p>
-            <a:pPr lvl="0" indent="0" marL="0">
-              <a:buNone/>
-            </a:pPr>
-            <a:r>
-              <a:rPr/>
               <a:t>더 깊이</a:t>
             </a:r>
           </a:p>
@@ -4288,8 +4116,8 @@
           </p:nvPr>
         </p:nvGraphicFramePr>
         <p:xfrm>
-          <a:off x="457200" y="1193800"/>
-          <a:ext cx="8229600" cy="3390900"/>
+          <a:off x="3568700" y="266700"/>
+          <a:ext cx="5105400" cy="5842000"/>
         </p:xfrm>
         <a:graphic>
           <a:graphicData uri="http://schemas.openxmlformats.org/drawingml/2006/table">
@@ -4298,8 +4126,8 @@
                 <a:tableStyleId>{5C22544A-7EE6-4342-B048-85BDC9FD1C3A}</a:tableStyleId>
               </a:tblPr>
               <a:tblGrid>
-                <a:gridCol w="1219200"/>
-                <a:gridCol w="7010400"/>
+                <a:gridCol w="762000"/>
+                <a:gridCol w="4343400"/>
               </a:tblGrid>
               <a:tr h="0">
                 <a:tc>
@@ -4446,15 +4274,70 @@
 </p:sld>
 </file>
 
+<file path=ppt/slides/slide7.xml><?xml version="1.0" encoding="utf-8"?>
+<p:sld xmlns:a="http://schemas.openxmlformats.org/drawingml/2006/main" xmlns:r="http://schemas.openxmlformats.org/officeDocument/2006/relationships" xmlns:p="http://schemas.openxmlformats.org/presentationml/2006/main">
+  <p:cSld>
+    <p:spTree>
+      <p:nvGrpSpPr>
+        <p:cNvPr id="1" name=""/>
+        <p:cNvGrpSpPr/>
+        <p:nvPr/>
+      </p:nvGrpSpPr>
+      <p:grpSpPr>
+        <a:xfrm>
+          <a:off x="0" y="0"/>
+          <a:ext cx="0" cy="0"/>
+          <a:chOff x="0" y="0"/>
+          <a:chExt cx="0" cy="0"/>
+        </a:xfrm>
+      </p:grpSpPr>
+      <p:sp>
+        <p:nvSpPr>
+          <p:cNvPr id="3" name="Content Placeholder 2"/>
+          <p:cNvSpPr>
+            <a:spLocks noGrp="1"/>
+          </p:cNvSpPr>
+          <p:nvPr>
+            <p:ph idx="1"/>
+          </p:nvPr>
+        </p:nvSpPr>
+        <p:spPr/>
+        <p:txBody>
+          <a:bodyPr/>
+          <a:lstStyle/>
+          <a:p>
+            <a:pPr lvl="0" indent="0" marL="1270000">
+              <a:buNone/>
+            </a:pPr>
+            <a:r>
+              <a:rPr sz="2000"/>
+              <a:t>Chapter Mode·내장 컴포넌트·저작 파이프라인은 </a:t>
+            </a:r>
+            <a:r>
+              <a:rPr sz="2000" b="1"/>
+              <a:t>m2slide Showcase</a:t>
+            </a:r>
+            <a:r>
+              <a:rPr sz="2000"/>
+              <a:t>에서 실습으로</a:t>
+            </a:r>
+          </a:p>
+        </p:txBody>
+      </p:sp>
+    </p:spTree>
+  </p:cSld>
+</p:sld>
+</file>
+
 <file path=ppt/theme/theme1.xml><?xml version="1.0" encoding="utf-8"?>
 <a:theme xmlns:a="http://schemas.openxmlformats.org/drawingml/2006/main" name="Office Theme">
   <a:themeElements>
     <a:clrScheme name="Office">
       <a:dk1>
-        <a:sysClr val="windowText" lastClr="000000"/>
+        <a:srgbClr val="1A1A1A"/>
       </a:dk1>
       <a:lt1>
-        <a:sysClr val="window" lastClr="FFFFFF"/>
+        <a:srgbClr val="FFFFFF"/>
       </a:lt1>
       <a:dk2>
         <a:srgbClr val="1F497D"/>
@@ -4463,22 +4346,22 @@
         <a:srgbClr val="EEECE1"/>
       </a:lt2>
       <a:accent1>
-        <a:srgbClr val="4F81BD"/>
+        <a:srgbClr val="F5C518"/>
       </a:accent1>
       <a:accent2>
-        <a:srgbClr val="C0504D"/>
+        <a:srgbClr val="FFE15A"/>
       </a:accent2>
       <a:accent3>
-        <a:srgbClr val="9BBB59"/>
+        <a:srgbClr val="C49D13"/>
       </a:accent3>
       <a:accent4>
-        <a:srgbClr val="8064A2"/>
+        <a:srgbClr val="977A0E"/>
       </a:accent4>
       <a:accent5>
-        <a:srgbClr val="4BACC6"/>
+        <a:srgbClr val="977A0E"/>
       </a:accent5>
       <a:accent6>
-        <a:srgbClr val="F79646"/>
+        <a:srgbClr val="977A0E"/>
       </a:accent6>
       <a:hlink>
         <a:srgbClr val="0000FF"/>
@@ -4489,8 +4372,8 @@
     </a:clrScheme>
     <a:fontScheme name="Office">
       <a:majorFont>
-        <a:latin typeface="Calibri"/>
-        <a:ea typeface=""/>
+        <a:latin typeface="Malgun Gothic"/>
+        <a:ea typeface="Malgun Gothic"/>
         <a:cs typeface=""/>
         <a:font script="Jpan" typeface="ＭＳ Ｐゴシック"/>
         <a:font script="Hang" typeface="맑은 고딕"/>
@@ -4524,8 +4407,8 @@
         <a:font script="Geor" typeface="Sylfaen"/>
       </a:majorFont>
       <a:minorFont>
-        <a:latin typeface="Calibri"/>
-        <a:ea typeface=""/>
+        <a:latin typeface="Malgun Gothic"/>
+        <a:ea typeface="Malgun Gothic"/>
         <a:cs typeface=""/>
         <a:font script="Jpan" typeface="ＭＳ Ｐゴシック"/>
         <a:font script="Hang" typeface="맑은 고딕"/>

</xml_diff>